<commit_message>
Tables: PowerPoint's built-in table styles for undefined style ids
Tables that name one of the 74 built-in styles without their
presentation defining it (as files from other producers do) take the
definition PowerPoint writes for it, kept as an engine resource.

Co-Authored-By: Claude Opus 5.5 <noreply@anthropic.com>
</commit_message>
<xml_diff>
--- a/tests/corpus/pptx/generated/tables-more.pptx
+++ b/tests/corpus/pptx/generated/tables-more.pptx
@@ -6,6 +6,7 @@
   </p:sldMasterIdLst>
   <p:sldIdLst>
     <p:sldId id="256" r:id="rId2"/>
+    <p:sldId id="257" r:id="rId3"/>
   </p:sldIdLst>
   <p:sldSz cx="12192000" cy="6858000"/>
   <p:notesSz cx="6858000" cy="9144000"/>
@@ -129,7 +130,7 @@
           <p:cNvPr id="2" name="Titel 1">
             <a:extLst>
               <a:ext uri="{FF2B5EF4-FFF2-40B4-BE49-F238E27FC236}">
-                <a16:creationId xmlns:a16="http://schemas.microsoft.com/office/drawing/2014/main" id="{56C83388-F5B7-8A70-381E-DE114FBBBAEF}"/>
+                <a16:creationId xmlns:a16="http://schemas.microsoft.com/office/drawing/2014/main" id="{7783872B-8A7F-0163-1D3D-0FA289380632}"/>
               </a:ext>
             </a:extLst>
           </p:cNvPr>
@@ -166,7 +167,7 @@
           <p:cNvPr id="3" name="Untertitel 2">
             <a:extLst>
               <a:ext uri="{FF2B5EF4-FFF2-40B4-BE49-F238E27FC236}">
-                <a16:creationId xmlns:a16="http://schemas.microsoft.com/office/drawing/2014/main" id="{09C8A7FE-3551-B11E-5999-4D024C64B923}"/>
+                <a16:creationId xmlns:a16="http://schemas.microsoft.com/office/drawing/2014/main" id="{A7428D0A-286B-8539-7474-21C00EBFE288}"/>
               </a:ext>
             </a:extLst>
           </p:cNvPr>
@@ -236,7 +237,7 @@
           <p:cNvPr id="4" name="Datumsplatzhalter 3">
             <a:extLst>
               <a:ext uri="{FF2B5EF4-FFF2-40B4-BE49-F238E27FC236}">
-                <a16:creationId xmlns:a16="http://schemas.microsoft.com/office/drawing/2014/main" id="{CFC66650-FEDF-E28C-2E85-77B0F99047EC}"/>
+                <a16:creationId xmlns:a16="http://schemas.microsoft.com/office/drawing/2014/main" id="{6D288DDA-28F0-3FD5-A7F6-8F4965C5979D}"/>
               </a:ext>
             </a:extLst>
           </p:cNvPr>
@@ -252,7 +253,7 @@
           <a:bodyPr/>
           <a:lstStyle/>
           <a:p>
-            <a:fld id="{83C4AB47-C71B-4E79-A3F3-AF6AEE09EA81}" type="datetimeFigureOut">
+            <a:fld id="{93B07367-803E-42B4-B6CC-0D4380B0C07C}" type="datetimeFigureOut">
               <a:rPr lang="de-DE" smtClean="0"/>
               <a:t>09.10.2026</a:t>
             </a:fld>
@@ -265,7 +266,7 @@
           <p:cNvPr id="5" name="Fußzeilenplatzhalter 4">
             <a:extLst>
               <a:ext uri="{FF2B5EF4-FFF2-40B4-BE49-F238E27FC236}">
-                <a16:creationId xmlns:a16="http://schemas.microsoft.com/office/drawing/2014/main" id="{591522CA-8229-2734-A638-BCD9992B2EAE}"/>
+                <a16:creationId xmlns:a16="http://schemas.microsoft.com/office/drawing/2014/main" id="{0F051AD6-8D93-9DDF-0046-53D7CB02EA03}"/>
               </a:ext>
             </a:extLst>
           </p:cNvPr>
@@ -290,7 +291,7 @@
           <p:cNvPr id="6" name="Foliennummernplatzhalter 5">
             <a:extLst>
               <a:ext uri="{FF2B5EF4-FFF2-40B4-BE49-F238E27FC236}">
-                <a16:creationId xmlns:a16="http://schemas.microsoft.com/office/drawing/2014/main" id="{D2381614-C633-9432-66DE-B5C72CC81856}"/>
+                <a16:creationId xmlns:a16="http://schemas.microsoft.com/office/drawing/2014/main" id="{A71026E8-8001-528B-7FBE-34974FE8C4CB}"/>
               </a:ext>
             </a:extLst>
           </p:cNvPr>
@@ -306,7 +307,7 @@
           <a:bodyPr/>
           <a:lstStyle/>
           <a:p>
-            <a:fld id="{56D4D39F-CBD4-4DCF-99B0-4CB27C07A787}" type="slidenum">
+            <a:fld id="{510660EA-E3F0-4E01-81FF-9EE36D78EF1F}" type="slidenum">
               <a:rPr lang="de-DE" smtClean="0"/>
               <a:t>‹Nr.›</a:t>
             </a:fld>
@@ -317,7 +318,7 @@
     </p:spTree>
     <p:extLst>
       <p:ext uri="{BB962C8B-B14F-4D97-AF65-F5344CB8AC3E}">
-        <p14:creationId xmlns:p14="http://schemas.microsoft.com/office/powerpoint/2010/main" val="624388128"/>
+        <p14:creationId xmlns:p14="http://schemas.microsoft.com/office/powerpoint/2010/main" val="1502396008"/>
       </p:ext>
     </p:extLst>
   </p:cSld>
@@ -349,7 +350,7 @@
           <p:cNvPr id="2" name="Titel 1">
             <a:extLst>
               <a:ext uri="{FF2B5EF4-FFF2-40B4-BE49-F238E27FC236}">
-                <a16:creationId xmlns:a16="http://schemas.microsoft.com/office/drawing/2014/main" id="{1549C9D5-2E5B-C6CE-5703-986C02A18CB3}"/>
+                <a16:creationId xmlns:a16="http://schemas.microsoft.com/office/drawing/2014/main" id="{E208BFB1-325F-A87C-A653-37C690383CCC}"/>
               </a:ext>
             </a:extLst>
           </p:cNvPr>
@@ -377,7 +378,7 @@
           <p:cNvPr id="3" name="Vertikaler Textplatzhalter 2">
             <a:extLst>
               <a:ext uri="{FF2B5EF4-FFF2-40B4-BE49-F238E27FC236}">
-                <a16:creationId xmlns:a16="http://schemas.microsoft.com/office/drawing/2014/main" id="{B7F61C7E-17DF-CD8B-70A5-BECFFF2EDC38}"/>
+                <a16:creationId xmlns:a16="http://schemas.microsoft.com/office/drawing/2014/main" id="{ABC5AA15-9271-36D3-CFEE-43E763A9AD5C}"/>
               </a:ext>
             </a:extLst>
           </p:cNvPr>
@@ -434,7 +435,7 @@
           <p:cNvPr id="4" name="Datumsplatzhalter 3">
             <a:extLst>
               <a:ext uri="{FF2B5EF4-FFF2-40B4-BE49-F238E27FC236}">
-                <a16:creationId xmlns:a16="http://schemas.microsoft.com/office/drawing/2014/main" id="{A0DB874B-39CB-780E-9533-8537D06EF1DD}"/>
+                <a16:creationId xmlns:a16="http://schemas.microsoft.com/office/drawing/2014/main" id="{E6EBEA59-AA66-5740-EAC6-250E9BD84232}"/>
               </a:ext>
             </a:extLst>
           </p:cNvPr>
@@ -450,7 +451,7 @@
           <a:bodyPr/>
           <a:lstStyle/>
           <a:p>
-            <a:fld id="{83C4AB47-C71B-4E79-A3F3-AF6AEE09EA81}" type="datetimeFigureOut">
+            <a:fld id="{93B07367-803E-42B4-B6CC-0D4380B0C07C}" type="datetimeFigureOut">
               <a:rPr lang="de-DE" smtClean="0"/>
               <a:t>09.10.2026</a:t>
             </a:fld>
@@ -463,7 +464,7 @@
           <p:cNvPr id="5" name="Fußzeilenplatzhalter 4">
             <a:extLst>
               <a:ext uri="{FF2B5EF4-FFF2-40B4-BE49-F238E27FC236}">
-                <a16:creationId xmlns:a16="http://schemas.microsoft.com/office/drawing/2014/main" id="{EC7D56C4-FE52-788B-4EE5-FFCE2FB05F16}"/>
+                <a16:creationId xmlns:a16="http://schemas.microsoft.com/office/drawing/2014/main" id="{36D5771D-AFD9-9B67-7CBB-C5D1410F6B8A}"/>
               </a:ext>
             </a:extLst>
           </p:cNvPr>
@@ -488,7 +489,7 @@
           <p:cNvPr id="6" name="Foliennummernplatzhalter 5">
             <a:extLst>
               <a:ext uri="{FF2B5EF4-FFF2-40B4-BE49-F238E27FC236}">
-                <a16:creationId xmlns:a16="http://schemas.microsoft.com/office/drawing/2014/main" id="{ECC8FA96-74AC-CBCD-4FB8-AABFB42197E0}"/>
+                <a16:creationId xmlns:a16="http://schemas.microsoft.com/office/drawing/2014/main" id="{ACD57028-FC9F-4B3B-6F29-FE80419B1BD3}"/>
               </a:ext>
             </a:extLst>
           </p:cNvPr>
@@ -504,7 +505,7 @@
           <a:bodyPr/>
           <a:lstStyle/>
           <a:p>
-            <a:fld id="{56D4D39F-CBD4-4DCF-99B0-4CB27C07A787}" type="slidenum">
+            <a:fld id="{510660EA-E3F0-4E01-81FF-9EE36D78EF1F}" type="slidenum">
               <a:rPr lang="de-DE" smtClean="0"/>
               <a:t>‹Nr.›</a:t>
             </a:fld>
@@ -515,7 +516,7 @@
     </p:spTree>
     <p:extLst>
       <p:ext uri="{BB962C8B-B14F-4D97-AF65-F5344CB8AC3E}">
-        <p14:creationId xmlns:p14="http://schemas.microsoft.com/office/powerpoint/2010/main" val="1203136494"/>
+        <p14:creationId xmlns:p14="http://schemas.microsoft.com/office/powerpoint/2010/main" val="709309378"/>
       </p:ext>
     </p:extLst>
   </p:cSld>
@@ -547,7 +548,7 @@
           <p:cNvPr id="2" name="Vertikaler Titel 1">
             <a:extLst>
               <a:ext uri="{FF2B5EF4-FFF2-40B4-BE49-F238E27FC236}">
-                <a16:creationId xmlns:a16="http://schemas.microsoft.com/office/drawing/2014/main" id="{8D5BB5EF-9374-7341-C5ED-C96DC3EEC77E}"/>
+                <a16:creationId xmlns:a16="http://schemas.microsoft.com/office/drawing/2014/main" id="{34CD313B-AA3E-BB51-19F5-B56F1D8C60F8}"/>
               </a:ext>
             </a:extLst>
           </p:cNvPr>
@@ -580,7 +581,7 @@
           <p:cNvPr id="3" name="Vertikaler Textplatzhalter 2">
             <a:extLst>
               <a:ext uri="{FF2B5EF4-FFF2-40B4-BE49-F238E27FC236}">
-                <a16:creationId xmlns:a16="http://schemas.microsoft.com/office/drawing/2014/main" id="{99B8ECC8-1719-81EA-BB8B-3A6D16CACAF0}"/>
+                <a16:creationId xmlns:a16="http://schemas.microsoft.com/office/drawing/2014/main" id="{CD20E99A-5F7A-7D71-912B-4AF499D41597}"/>
               </a:ext>
             </a:extLst>
           </p:cNvPr>
@@ -642,7 +643,7 @@
           <p:cNvPr id="4" name="Datumsplatzhalter 3">
             <a:extLst>
               <a:ext uri="{FF2B5EF4-FFF2-40B4-BE49-F238E27FC236}">
-                <a16:creationId xmlns:a16="http://schemas.microsoft.com/office/drawing/2014/main" id="{3D690B16-B033-69FE-B2B3-E48C09BB5FFF}"/>
+                <a16:creationId xmlns:a16="http://schemas.microsoft.com/office/drawing/2014/main" id="{E8079F6B-6848-55C7-6CBE-EEB97245C219}"/>
               </a:ext>
             </a:extLst>
           </p:cNvPr>
@@ -658,7 +659,7 @@
           <a:bodyPr/>
           <a:lstStyle/>
           <a:p>
-            <a:fld id="{83C4AB47-C71B-4E79-A3F3-AF6AEE09EA81}" type="datetimeFigureOut">
+            <a:fld id="{93B07367-803E-42B4-B6CC-0D4380B0C07C}" type="datetimeFigureOut">
               <a:rPr lang="de-DE" smtClean="0"/>
               <a:t>09.10.2026</a:t>
             </a:fld>
@@ -671,7 +672,7 @@
           <p:cNvPr id="5" name="Fußzeilenplatzhalter 4">
             <a:extLst>
               <a:ext uri="{FF2B5EF4-FFF2-40B4-BE49-F238E27FC236}">
-                <a16:creationId xmlns:a16="http://schemas.microsoft.com/office/drawing/2014/main" id="{8C1BC9A5-1F73-E1D2-2CA2-A9ED97F98244}"/>
+                <a16:creationId xmlns:a16="http://schemas.microsoft.com/office/drawing/2014/main" id="{754ED242-6511-3D1F-C891-08D35D1EBC48}"/>
               </a:ext>
             </a:extLst>
           </p:cNvPr>
@@ -696,7 +697,7 @@
           <p:cNvPr id="6" name="Foliennummernplatzhalter 5">
             <a:extLst>
               <a:ext uri="{FF2B5EF4-FFF2-40B4-BE49-F238E27FC236}">
-                <a16:creationId xmlns:a16="http://schemas.microsoft.com/office/drawing/2014/main" id="{6EC176A8-F022-E9B7-74E3-DD1B24BBA096}"/>
+                <a16:creationId xmlns:a16="http://schemas.microsoft.com/office/drawing/2014/main" id="{2CEA4EEC-224C-77F6-A9BD-6F244B7CB3B4}"/>
               </a:ext>
             </a:extLst>
           </p:cNvPr>
@@ -712,7 +713,7 @@
           <a:bodyPr/>
           <a:lstStyle/>
           <a:p>
-            <a:fld id="{56D4D39F-CBD4-4DCF-99B0-4CB27C07A787}" type="slidenum">
+            <a:fld id="{510660EA-E3F0-4E01-81FF-9EE36D78EF1F}" type="slidenum">
               <a:rPr lang="de-DE" smtClean="0"/>
               <a:t>‹Nr.›</a:t>
             </a:fld>
@@ -723,7 +724,7 @@
     </p:spTree>
     <p:extLst>
       <p:ext uri="{BB962C8B-B14F-4D97-AF65-F5344CB8AC3E}">
-        <p14:creationId xmlns:p14="http://schemas.microsoft.com/office/powerpoint/2010/main" val="1291540079"/>
+        <p14:creationId xmlns:p14="http://schemas.microsoft.com/office/powerpoint/2010/main" val="2988010887"/>
       </p:ext>
     </p:extLst>
   </p:cSld>
@@ -755,7 +756,7 @@
           <p:cNvPr id="2" name="Titel 1">
             <a:extLst>
               <a:ext uri="{FF2B5EF4-FFF2-40B4-BE49-F238E27FC236}">
-                <a16:creationId xmlns:a16="http://schemas.microsoft.com/office/drawing/2014/main" id="{616F7583-5201-66D8-D185-776BDC421130}"/>
+                <a16:creationId xmlns:a16="http://schemas.microsoft.com/office/drawing/2014/main" id="{1D802024-357C-0322-5C42-AA0E47C3F048}"/>
               </a:ext>
             </a:extLst>
           </p:cNvPr>
@@ -783,7 +784,7 @@
           <p:cNvPr id="3" name="Inhaltsplatzhalter 2">
             <a:extLst>
               <a:ext uri="{FF2B5EF4-FFF2-40B4-BE49-F238E27FC236}">
-                <a16:creationId xmlns:a16="http://schemas.microsoft.com/office/drawing/2014/main" id="{859D4621-8749-9A3B-8055-13EB5A58E9CA}"/>
+                <a16:creationId xmlns:a16="http://schemas.microsoft.com/office/drawing/2014/main" id="{D5590866-74BE-E4D0-E5FB-63F62381A50A}"/>
               </a:ext>
             </a:extLst>
           </p:cNvPr>
@@ -840,7 +841,7 @@
           <p:cNvPr id="4" name="Datumsplatzhalter 3">
             <a:extLst>
               <a:ext uri="{FF2B5EF4-FFF2-40B4-BE49-F238E27FC236}">
-                <a16:creationId xmlns:a16="http://schemas.microsoft.com/office/drawing/2014/main" id="{8B62B7EE-39BA-ECAE-FB71-98F05F69FFF9}"/>
+                <a16:creationId xmlns:a16="http://schemas.microsoft.com/office/drawing/2014/main" id="{E6D3BBEA-E91C-F5FB-31C9-930F66C0990E}"/>
               </a:ext>
             </a:extLst>
           </p:cNvPr>
@@ -856,7 +857,7 @@
           <a:bodyPr/>
           <a:lstStyle/>
           <a:p>
-            <a:fld id="{83C4AB47-C71B-4E79-A3F3-AF6AEE09EA81}" type="datetimeFigureOut">
+            <a:fld id="{93B07367-803E-42B4-B6CC-0D4380B0C07C}" type="datetimeFigureOut">
               <a:rPr lang="de-DE" smtClean="0"/>
               <a:t>09.10.2026</a:t>
             </a:fld>
@@ -869,7 +870,7 @@
           <p:cNvPr id="5" name="Fußzeilenplatzhalter 4">
             <a:extLst>
               <a:ext uri="{FF2B5EF4-FFF2-40B4-BE49-F238E27FC236}">
-                <a16:creationId xmlns:a16="http://schemas.microsoft.com/office/drawing/2014/main" id="{8F041430-FDDA-A00F-CFB1-2DA181EC9228}"/>
+                <a16:creationId xmlns:a16="http://schemas.microsoft.com/office/drawing/2014/main" id="{D26A9354-9093-D1A8-5A75-85288FA01457}"/>
               </a:ext>
             </a:extLst>
           </p:cNvPr>
@@ -894,7 +895,7 @@
           <p:cNvPr id="6" name="Foliennummernplatzhalter 5">
             <a:extLst>
               <a:ext uri="{FF2B5EF4-FFF2-40B4-BE49-F238E27FC236}">
-                <a16:creationId xmlns:a16="http://schemas.microsoft.com/office/drawing/2014/main" id="{89D54879-59FD-6B40-64A6-E46F88BFF319}"/>
+                <a16:creationId xmlns:a16="http://schemas.microsoft.com/office/drawing/2014/main" id="{CCB884D6-185A-2C27-EC65-289EB9E30B8B}"/>
               </a:ext>
             </a:extLst>
           </p:cNvPr>
@@ -910,7 +911,7 @@
           <a:bodyPr/>
           <a:lstStyle/>
           <a:p>
-            <a:fld id="{56D4D39F-CBD4-4DCF-99B0-4CB27C07A787}" type="slidenum">
+            <a:fld id="{510660EA-E3F0-4E01-81FF-9EE36D78EF1F}" type="slidenum">
               <a:rPr lang="de-DE" smtClean="0"/>
               <a:t>‹Nr.›</a:t>
             </a:fld>
@@ -921,7 +922,7 @@
     </p:spTree>
     <p:extLst>
       <p:ext uri="{BB962C8B-B14F-4D97-AF65-F5344CB8AC3E}">
-        <p14:creationId xmlns:p14="http://schemas.microsoft.com/office/powerpoint/2010/main" val="1374985051"/>
+        <p14:creationId xmlns:p14="http://schemas.microsoft.com/office/powerpoint/2010/main" val="2116637557"/>
       </p:ext>
     </p:extLst>
   </p:cSld>
@@ -953,7 +954,7 @@
           <p:cNvPr id="2" name="Titel 1">
             <a:extLst>
               <a:ext uri="{FF2B5EF4-FFF2-40B4-BE49-F238E27FC236}">
-                <a16:creationId xmlns:a16="http://schemas.microsoft.com/office/drawing/2014/main" id="{8ECF554C-AE25-4770-0CBE-C37A788D014A}"/>
+                <a16:creationId xmlns:a16="http://schemas.microsoft.com/office/drawing/2014/main" id="{F0391057-0D62-932A-D848-EAB486BB6479}"/>
               </a:ext>
             </a:extLst>
           </p:cNvPr>
@@ -990,7 +991,7 @@
           <p:cNvPr id="3" name="Textplatzhalter 2">
             <a:extLst>
               <a:ext uri="{FF2B5EF4-FFF2-40B4-BE49-F238E27FC236}">
-                <a16:creationId xmlns:a16="http://schemas.microsoft.com/office/drawing/2014/main" id="{09D07F53-6D59-4504-D67E-011A7E0D67C8}"/>
+                <a16:creationId xmlns:a16="http://schemas.microsoft.com/office/drawing/2014/main" id="{44FDC209-B5DB-D99D-3313-592D03982E16}"/>
               </a:ext>
             </a:extLst>
           </p:cNvPr>
@@ -1115,7 +1116,7 @@
           <p:cNvPr id="4" name="Datumsplatzhalter 3">
             <a:extLst>
               <a:ext uri="{FF2B5EF4-FFF2-40B4-BE49-F238E27FC236}">
-                <a16:creationId xmlns:a16="http://schemas.microsoft.com/office/drawing/2014/main" id="{1631B4E0-6F8E-7EAE-C7B0-FE9648F31250}"/>
+                <a16:creationId xmlns:a16="http://schemas.microsoft.com/office/drawing/2014/main" id="{91C08D9B-382E-5D97-DE93-3DD6C4F6F513}"/>
               </a:ext>
             </a:extLst>
           </p:cNvPr>
@@ -1131,7 +1132,7 @@
           <a:bodyPr/>
           <a:lstStyle/>
           <a:p>
-            <a:fld id="{83C4AB47-C71B-4E79-A3F3-AF6AEE09EA81}" type="datetimeFigureOut">
+            <a:fld id="{93B07367-803E-42B4-B6CC-0D4380B0C07C}" type="datetimeFigureOut">
               <a:rPr lang="de-DE" smtClean="0"/>
               <a:t>09.10.2026</a:t>
             </a:fld>
@@ -1144,7 +1145,7 @@
           <p:cNvPr id="5" name="Fußzeilenplatzhalter 4">
             <a:extLst>
               <a:ext uri="{FF2B5EF4-FFF2-40B4-BE49-F238E27FC236}">
-                <a16:creationId xmlns:a16="http://schemas.microsoft.com/office/drawing/2014/main" id="{6772AE55-B869-E8FE-4CDB-E0BD8101D9F1}"/>
+                <a16:creationId xmlns:a16="http://schemas.microsoft.com/office/drawing/2014/main" id="{423B65DE-E5DD-F4B4-A43F-F05D974BC81A}"/>
               </a:ext>
             </a:extLst>
           </p:cNvPr>
@@ -1169,7 +1170,7 @@
           <p:cNvPr id="6" name="Foliennummernplatzhalter 5">
             <a:extLst>
               <a:ext uri="{FF2B5EF4-FFF2-40B4-BE49-F238E27FC236}">
-                <a16:creationId xmlns:a16="http://schemas.microsoft.com/office/drawing/2014/main" id="{0D7DCBA8-9421-3863-1427-E3E9CF710F1C}"/>
+                <a16:creationId xmlns:a16="http://schemas.microsoft.com/office/drawing/2014/main" id="{27619C07-BF86-8951-5D5B-44025F27F80E}"/>
               </a:ext>
             </a:extLst>
           </p:cNvPr>
@@ -1185,7 +1186,7 @@
           <a:bodyPr/>
           <a:lstStyle/>
           <a:p>
-            <a:fld id="{56D4D39F-CBD4-4DCF-99B0-4CB27C07A787}" type="slidenum">
+            <a:fld id="{510660EA-E3F0-4E01-81FF-9EE36D78EF1F}" type="slidenum">
               <a:rPr lang="de-DE" smtClean="0"/>
               <a:t>‹Nr.›</a:t>
             </a:fld>
@@ -1196,7 +1197,7 @@
     </p:spTree>
     <p:extLst>
       <p:ext uri="{BB962C8B-B14F-4D97-AF65-F5344CB8AC3E}">
-        <p14:creationId xmlns:p14="http://schemas.microsoft.com/office/powerpoint/2010/main" val="1917812838"/>
+        <p14:creationId xmlns:p14="http://schemas.microsoft.com/office/powerpoint/2010/main" val="1302042733"/>
       </p:ext>
     </p:extLst>
   </p:cSld>
@@ -1228,7 +1229,7 @@
           <p:cNvPr id="2" name="Titel 1">
             <a:extLst>
               <a:ext uri="{FF2B5EF4-FFF2-40B4-BE49-F238E27FC236}">
-                <a16:creationId xmlns:a16="http://schemas.microsoft.com/office/drawing/2014/main" id="{61C141B4-30FD-493E-B26E-6F063D63F4DB}"/>
+                <a16:creationId xmlns:a16="http://schemas.microsoft.com/office/drawing/2014/main" id="{551538DD-E3F5-E97A-6619-600610F143FC}"/>
               </a:ext>
             </a:extLst>
           </p:cNvPr>
@@ -1256,7 +1257,7 @@
           <p:cNvPr id="3" name="Inhaltsplatzhalter 2">
             <a:extLst>
               <a:ext uri="{FF2B5EF4-FFF2-40B4-BE49-F238E27FC236}">
-                <a16:creationId xmlns:a16="http://schemas.microsoft.com/office/drawing/2014/main" id="{CFDE911B-CC9D-8A3E-E250-B30E9297C306}"/>
+                <a16:creationId xmlns:a16="http://schemas.microsoft.com/office/drawing/2014/main" id="{B353B19C-D7C4-DB76-C7E6-D555536CB3A7}"/>
               </a:ext>
             </a:extLst>
           </p:cNvPr>
@@ -1318,7 +1319,7 @@
           <p:cNvPr id="4" name="Inhaltsplatzhalter 3">
             <a:extLst>
               <a:ext uri="{FF2B5EF4-FFF2-40B4-BE49-F238E27FC236}">
-                <a16:creationId xmlns:a16="http://schemas.microsoft.com/office/drawing/2014/main" id="{CA5D3148-54C7-1EAF-272F-91ACEEC178BC}"/>
+                <a16:creationId xmlns:a16="http://schemas.microsoft.com/office/drawing/2014/main" id="{9A8D510D-B5C7-E898-63F3-1C36DC959B60}"/>
               </a:ext>
             </a:extLst>
           </p:cNvPr>
@@ -1380,7 +1381,7 @@
           <p:cNvPr id="5" name="Datumsplatzhalter 4">
             <a:extLst>
               <a:ext uri="{FF2B5EF4-FFF2-40B4-BE49-F238E27FC236}">
-                <a16:creationId xmlns:a16="http://schemas.microsoft.com/office/drawing/2014/main" id="{3ABE1753-31E6-12A9-C8AB-7A53B4EBDD41}"/>
+                <a16:creationId xmlns:a16="http://schemas.microsoft.com/office/drawing/2014/main" id="{F6F81DE6-1E65-EFCF-32E0-B20BC297AEC1}"/>
               </a:ext>
             </a:extLst>
           </p:cNvPr>
@@ -1396,7 +1397,7 @@
           <a:bodyPr/>
           <a:lstStyle/>
           <a:p>
-            <a:fld id="{83C4AB47-C71B-4E79-A3F3-AF6AEE09EA81}" type="datetimeFigureOut">
+            <a:fld id="{93B07367-803E-42B4-B6CC-0D4380B0C07C}" type="datetimeFigureOut">
               <a:rPr lang="de-DE" smtClean="0"/>
               <a:t>09.10.2026</a:t>
             </a:fld>
@@ -1409,7 +1410,7 @@
           <p:cNvPr id="6" name="Fußzeilenplatzhalter 5">
             <a:extLst>
               <a:ext uri="{FF2B5EF4-FFF2-40B4-BE49-F238E27FC236}">
-                <a16:creationId xmlns:a16="http://schemas.microsoft.com/office/drawing/2014/main" id="{A1F16E0C-F7F1-C246-30DE-5682FAD940C7}"/>
+                <a16:creationId xmlns:a16="http://schemas.microsoft.com/office/drawing/2014/main" id="{97651BC1-9CFB-311A-4A89-15F7829118C6}"/>
               </a:ext>
             </a:extLst>
           </p:cNvPr>
@@ -1434,7 +1435,7 @@
           <p:cNvPr id="7" name="Foliennummernplatzhalter 6">
             <a:extLst>
               <a:ext uri="{FF2B5EF4-FFF2-40B4-BE49-F238E27FC236}">
-                <a16:creationId xmlns:a16="http://schemas.microsoft.com/office/drawing/2014/main" id="{659E497C-AA7B-D9E5-DD7C-0C166BB00C0F}"/>
+                <a16:creationId xmlns:a16="http://schemas.microsoft.com/office/drawing/2014/main" id="{AB4E00DC-C6BE-8167-1EB2-8C45424DB551}"/>
               </a:ext>
             </a:extLst>
           </p:cNvPr>
@@ -1450,7 +1451,7 @@
           <a:bodyPr/>
           <a:lstStyle/>
           <a:p>
-            <a:fld id="{56D4D39F-CBD4-4DCF-99B0-4CB27C07A787}" type="slidenum">
+            <a:fld id="{510660EA-E3F0-4E01-81FF-9EE36D78EF1F}" type="slidenum">
               <a:rPr lang="de-DE" smtClean="0"/>
               <a:t>‹Nr.›</a:t>
             </a:fld>
@@ -1461,7 +1462,7 @@
     </p:spTree>
     <p:extLst>
       <p:ext uri="{BB962C8B-B14F-4D97-AF65-F5344CB8AC3E}">
-        <p14:creationId xmlns:p14="http://schemas.microsoft.com/office/powerpoint/2010/main" val="4232956068"/>
+        <p14:creationId xmlns:p14="http://schemas.microsoft.com/office/powerpoint/2010/main" val="2789968777"/>
       </p:ext>
     </p:extLst>
   </p:cSld>
@@ -1493,7 +1494,7 @@
           <p:cNvPr id="2" name="Titel 1">
             <a:extLst>
               <a:ext uri="{FF2B5EF4-FFF2-40B4-BE49-F238E27FC236}">
-                <a16:creationId xmlns:a16="http://schemas.microsoft.com/office/drawing/2014/main" id="{64F84C41-F8D0-61C0-68F0-6AD9537FE4C8}"/>
+                <a16:creationId xmlns:a16="http://schemas.microsoft.com/office/drawing/2014/main" id="{AF3605E3-410B-8D6C-2AAE-63B13B769E93}"/>
               </a:ext>
             </a:extLst>
           </p:cNvPr>
@@ -1526,7 +1527,7 @@
           <p:cNvPr id="3" name="Textplatzhalter 2">
             <a:extLst>
               <a:ext uri="{FF2B5EF4-FFF2-40B4-BE49-F238E27FC236}">
-                <a16:creationId xmlns:a16="http://schemas.microsoft.com/office/drawing/2014/main" id="{CB0B36D2-FFE9-24C1-2024-29C679BE5329}"/>
+                <a16:creationId xmlns:a16="http://schemas.microsoft.com/office/drawing/2014/main" id="{560C0FA8-AFFC-60F6-9F3B-37763DA9ADBF}"/>
               </a:ext>
             </a:extLst>
           </p:cNvPr>
@@ -1597,7 +1598,7 @@
           <p:cNvPr id="4" name="Inhaltsplatzhalter 3">
             <a:extLst>
               <a:ext uri="{FF2B5EF4-FFF2-40B4-BE49-F238E27FC236}">
-                <a16:creationId xmlns:a16="http://schemas.microsoft.com/office/drawing/2014/main" id="{40A19114-C952-7F0E-91E0-A8110BD9EA3F}"/>
+                <a16:creationId xmlns:a16="http://schemas.microsoft.com/office/drawing/2014/main" id="{CA152A9B-1800-A196-C260-FD592E3A54B3}"/>
               </a:ext>
             </a:extLst>
           </p:cNvPr>
@@ -1659,7 +1660,7 @@
           <p:cNvPr id="5" name="Textplatzhalter 4">
             <a:extLst>
               <a:ext uri="{FF2B5EF4-FFF2-40B4-BE49-F238E27FC236}">
-                <a16:creationId xmlns:a16="http://schemas.microsoft.com/office/drawing/2014/main" id="{7760F850-5B8F-D1A3-20E7-6AA1EB4BF2CC}"/>
+                <a16:creationId xmlns:a16="http://schemas.microsoft.com/office/drawing/2014/main" id="{1C622FA2-C275-5825-09FB-BC0762EDD87F}"/>
               </a:ext>
             </a:extLst>
           </p:cNvPr>
@@ -1730,7 +1731,7 @@
           <p:cNvPr id="6" name="Inhaltsplatzhalter 5">
             <a:extLst>
               <a:ext uri="{FF2B5EF4-FFF2-40B4-BE49-F238E27FC236}">
-                <a16:creationId xmlns:a16="http://schemas.microsoft.com/office/drawing/2014/main" id="{44FEE8FB-C796-A50E-48BB-8535FA460E66}"/>
+                <a16:creationId xmlns:a16="http://schemas.microsoft.com/office/drawing/2014/main" id="{0C750C98-844E-3E0B-0849-8373376AC9E1}"/>
               </a:ext>
             </a:extLst>
           </p:cNvPr>
@@ -1792,7 +1793,7 @@
           <p:cNvPr id="7" name="Datumsplatzhalter 6">
             <a:extLst>
               <a:ext uri="{FF2B5EF4-FFF2-40B4-BE49-F238E27FC236}">
-                <a16:creationId xmlns:a16="http://schemas.microsoft.com/office/drawing/2014/main" id="{ED14DA8D-336D-AFEF-DFC2-DE3E8F2C5B22}"/>
+                <a16:creationId xmlns:a16="http://schemas.microsoft.com/office/drawing/2014/main" id="{9208D146-587B-761F-F1E6-CD2500081019}"/>
               </a:ext>
             </a:extLst>
           </p:cNvPr>
@@ -1808,7 +1809,7 @@
           <a:bodyPr/>
           <a:lstStyle/>
           <a:p>
-            <a:fld id="{83C4AB47-C71B-4E79-A3F3-AF6AEE09EA81}" type="datetimeFigureOut">
+            <a:fld id="{93B07367-803E-42B4-B6CC-0D4380B0C07C}" type="datetimeFigureOut">
               <a:rPr lang="de-DE" smtClean="0"/>
               <a:t>09.10.2026</a:t>
             </a:fld>
@@ -1821,7 +1822,7 @@
           <p:cNvPr id="8" name="Fußzeilenplatzhalter 7">
             <a:extLst>
               <a:ext uri="{FF2B5EF4-FFF2-40B4-BE49-F238E27FC236}">
-                <a16:creationId xmlns:a16="http://schemas.microsoft.com/office/drawing/2014/main" id="{611C53F6-5FCA-13E7-36C4-F53807443A11}"/>
+                <a16:creationId xmlns:a16="http://schemas.microsoft.com/office/drawing/2014/main" id="{1E3B60FF-A80B-CF90-378D-C0ABDAEC2F4C}"/>
               </a:ext>
             </a:extLst>
           </p:cNvPr>
@@ -1846,7 +1847,7 @@
           <p:cNvPr id="9" name="Foliennummernplatzhalter 8">
             <a:extLst>
               <a:ext uri="{FF2B5EF4-FFF2-40B4-BE49-F238E27FC236}">
-                <a16:creationId xmlns:a16="http://schemas.microsoft.com/office/drawing/2014/main" id="{68908341-A0B2-700C-1209-F0F9A4A6B1E1}"/>
+                <a16:creationId xmlns:a16="http://schemas.microsoft.com/office/drawing/2014/main" id="{D6FC9FC1-5850-397B-3529-203C6140E692}"/>
               </a:ext>
             </a:extLst>
           </p:cNvPr>
@@ -1862,7 +1863,7 @@
           <a:bodyPr/>
           <a:lstStyle/>
           <a:p>
-            <a:fld id="{56D4D39F-CBD4-4DCF-99B0-4CB27C07A787}" type="slidenum">
+            <a:fld id="{510660EA-E3F0-4E01-81FF-9EE36D78EF1F}" type="slidenum">
               <a:rPr lang="de-DE" smtClean="0"/>
               <a:t>‹Nr.›</a:t>
             </a:fld>
@@ -1873,7 +1874,7 @@
     </p:spTree>
     <p:extLst>
       <p:ext uri="{BB962C8B-B14F-4D97-AF65-F5344CB8AC3E}">
-        <p14:creationId xmlns:p14="http://schemas.microsoft.com/office/powerpoint/2010/main" val="4144514835"/>
+        <p14:creationId xmlns:p14="http://schemas.microsoft.com/office/powerpoint/2010/main" val="992887505"/>
       </p:ext>
     </p:extLst>
   </p:cSld>
@@ -1905,7 +1906,7 @@
           <p:cNvPr id="2" name="Titel 1">
             <a:extLst>
               <a:ext uri="{FF2B5EF4-FFF2-40B4-BE49-F238E27FC236}">
-                <a16:creationId xmlns:a16="http://schemas.microsoft.com/office/drawing/2014/main" id="{AB2D4487-B665-D103-C8B2-2B7EA10EE9B3}"/>
+                <a16:creationId xmlns:a16="http://schemas.microsoft.com/office/drawing/2014/main" id="{CE61771F-FDF7-887A-48B5-85F18E42369B}"/>
               </a:ext>
             </a:extLst>
           </p:cNvPr>
@@ -1933,7 +1934,7 @@
           <p:cNvPr id="3" name="Datumsplatzhalter 2">
             <a:extLst>
               <a:ext uri="{FF2B5EF4-FFF2-40B4-BE49-F238E27FC236}">
-                <a16:creationId xmlns:a16="http://schemas.microsoft.com/office/drawing/2014/main" id="{32B99473-E750-DA27-AA37-0E384AD9E2D7}"/>
+                <a16:creationId xmlns:a16="http://schemas.microsoft.com/office/drawing/2014/main" id="{5CB5BF2D-59BE-A87A-F33E-087994556152}"/>
               </a:ext>
             </a:extLst>
           </p:cNvPr>
@@ -1949,7 +1950,7 @@
           <a:bodyPr/>
           <a:lstStyle/>
           <a:p>
-            <a:fld id="{83C4AB47-C71B-4E79-A3F3-AF6AEE09EA81}" type="datetimeFigureOut">
+            <a:fld id="{93B07367-803E-42B4-B6CC-0D4380B0C07C}" type="datetimeFigureOut">
               <a:rPr lang="de-DE" smtClean="0"/>
               <a:t>09.10.2026</a:t>
             </a:fld>
@@ -1962,7 +1963,7 @@
           <p:cNvPr id="4" name="Fußzeilenplatzhalter 3">
             <a:extLst>
               <a:ext uri="{FF2B5EF4-FFF2-40B4-BE49-F238E27FC236}">
-                <a16:creationId xmlns:a16="http://schemas.microsoft.com/office/drawing/2014/main" id="{7C3F60D1-5C76-79E7-184A-E12F9224AE78}"/>
+                <a16:creationId xmlns:a16="http://schemas.microsoft.com/office/drawing/2014/main" id="{DA148C56-AF4D-603A-EE38-DF581EFAEFE3}"/>
               </a:ext>
             </a:extLst>
           </p:cNvPr>
@@ -1987,7 +1988,7 @@
           <p:cNvPr id="5" name="Foliennummernplatzhalter 4">
             <a:extLst>
               <a:ext uri="{FF2B5EF4-FFF2-40B4-BE49-F238E27FC236}">
-                <a16:creationId xmlns:a16="http://schemas.microsoft.com/office/drawing/2014/main" id="{A8526F46-7974-F21A-2CDF-C12BD238A174}"/>
+                <a16:creationId xmlns:a16="http://schemas.microsoft.com/office/drawing/2014/main" id="{A8266B63-F655-0596-89F1-6A9EEC91E4F9}"/>
               </a:ext>
             </a:extLst>
           </p:cNvPr>
@@ -2003,7 +2004,7 @@
           <a:bodyPr/>
           <a:lstStyle/>
           <a:p>
-            <a:fld id="{56D4D39F-CBD4-4DCF-99B0-4CB27C07A787}" type="slidenum">
+            <a:fld id="{510660EA-E3F0-4E01-81FF-9EE36D78EF1F}" type="slidenum">
               <a:rPr lang="de-DE" smtClean="0"/>
               <a:t>‹Nr.›</a:t>
             </a:fld>
@@ -2014,7 +2015,7 @@
     </p:spTree>
     <p:extLst>
       <p:ext uri="{BB962C8B-B14F-4D97-AF65-F5344CB8AC3E}">
-        <p14:creationId xmlns:p14="http://schemas.microsoft.com/office/powerpoint/2010/main" val="4090897266"/>
+        <p14:creationId xmlns:p14="http://schemas.microsoft.com/office/powerpoint/2010/main" val="3889640711"/>
       </p:ext>
     </p:extLst>
   </p:cSld>
@@ -2046,7 +2047,7 @@
           <p:cNvPr id="2" name="Datumsplatzhalter 1">
             <a:extLst>
               <a:ext uri="{FF2B5EF4-FFF2-40B4-BE49-F238E27FC236}">
-                <a16:creationId xmlns:a16="http://schemas.microsoft.com/office/drawing/2014/main" id="{0F09F4E7-1321-7DA7-9602-F820121DF247}"/>
+                <a16:creationId xmlns:a16="http://schemas.microsoft.com/office/drawing/2014/main" id="{8E2736CC-5CC0-2AD9-8F83-1E3955655531}"/>
               </a:ext>
             </a:extLst>
           </p:cNvPr>
@@ -2062,7 +2063,7 @@
           <a:bodyPr/>
           <a:lstStyle/>
           <a:p>
-            <a:fld id="{83C4AB47-C71B-4E79-A3F3-AF6AEE09EA81}" type="datetimeFigureOut">
+            <a:fld id="{93B07367-803E-42B4-B6CC-0D4380B0C07C}" type="datetimeFigureOut">
               <a:rPr lang="de-DE" smtClean="0"/>
               <a:t>09.10.2026</a:t>
             </a:fld>
@@ -2075,7 +2076,7 @@
           <p:cNvPr id="3" name="Fußzeilenplatzhalter 2">
             <a:extLst>
               <a:ext uri="{FF2B5EF4-FFF2-40B4-BE49-F238E27FC236}">
-                <a16:creationId xmlns:a16="http://schemas.microsoft.com/office/drawing/2014/main" id="{C2932A24-DDE9-38BF-1691-45C42047AD72}"/>
+                <a16:creationId xmlns:a16="http://schemas.microsoft.com/office/drawing/2014/main" id="{5BA8C6CB-D9FE-B473-7320-172351F2A9F4}"/>
               </a:ext>
             </a:extLst>
           </p:cNvPr>
@@ -2100,7 +2101,7 @@
           <p:cNvPr id="4" name="Foliennummernplatzhalter 3">
             <a:extLst>
               <a:ext uri="{FF2B5EF4-FFF2-40B4-BE49-F238E27FC236}">
-                <a16:creationId xmlns:a16="http://schemas.microsoft.com/office/drawing/2014/main" id="{2063BD17-AF6F-4366-E380-F374737DC900}"/>
+                <a16:creationId xmlns:a16="http://schemas.microsoft.com/office/drawing/2014/main" id="{DD13458E-C42A-08AF-51B1-788DBFA0474F}"/>
               </a:ext>
             </a:extLst>
           </p:cNvPr>
@@ -2116,7 +2117,7 @@
           <a:bodyPr/>
           <a:lstStyle/>
           <a:p>
-            <a:fld id="{56D4D39F-CBD4-4DCF-99B0-4CB27C07A787}" type="slidenum">
+            <a:fld id="{510660EA-E3F0-4E01-81FF-9EE36D78EF1F}" type="slidenum">
               <a:rPr lang="de-DE" smtClean="0"/>
               <a:t>‹Nr.›</a:t>
             </a:fld>
@@ -2127,7 +2128,7 @@
     </p:spTree>
     <p:extLst>
       <p:ext uri="{BB962C8B-B14F-4D97-AF65-F5344CB8AC3E}">
-        <p14:creationId xmlns:p14="http://schemas.microsoft.com/office/powerpoint/2010/main" val="3197625522"/>
+        <p14:creationId xmlns:p14="http://schemas.microsoft.com/office/powerpoint/2010/main" val="2407796572"/>
       </p:ext>
     </p:extLst>
   </p:cSld>
@@ -2159,7 +2160,7 @@
           <p:cNvPr id="2" name="Titel 1">
             <a:extLst>
               <a:ext uri="{FF2B5EF4-FFF2-40B4-BE49-F238E27FC236}">
-                <a16:creationId xmlns:a16="http://schemas.microsoft.com/office/drawing/2014/main" id="{CD0A0BFB-9C9A-6295-EBBA-3A89BBF0EE1A}"/>
+                <a16:creationId xmlns:a16="http://schemas.microsoft.com/office/drawing/2014/main" id="{4EEFDD37-FF39-EA58-0E38-790520DB3951}"/>
               </a:ext>
             </a:extLst>
           </p:cNvPr>
@@ -2196,7 +2197,7 @@
           <p:cNvPr id="3" name="Inhaltsplatzhalter 2">
             <a:extLst>
               <a:ext uri="{FF2B5EF4-FFF2-40B4-BE49-F238E27FC236}">
-                <a16:creationId xmlns:a16="http://schemas.microsoft.com/office/drawing/2014/main" id="{792DF4EE-457A-B6E4-E11F-D867EC8A8ACC}"/>
+                <a16:creationId xmlns:a16="http://schemas.microsoft.com/office/drawing/2014/main" id="{BADCB77C-15FD-C277-A935-64E1691EFD74}"/>
               </a:ext>
             </a:extLst>
           </p:cNvPr>
@@ -2286,7 +2287,7 @@
           <p:cNvPr id="4" name="Textplatzhalter 3">
             <a:extLst>
               <a:ext uri="{FF2B5EF4-FFF2-40B4-BE49-F238E27FC236}">
-                <a16:creationId xmlns:a16="http://schemas.microsoft.com/office/drawing/2014/main" id="{2EF98716-3E70-9424-A753-A6F7E25B3912}"/>
+                <a16:creationId xmlns:a16="http://schemas.microsoft.com/office/drawing/2014/main" id="{4FAAEFAA-D925-77FE-F3BD-97D886D95093}"/>
               </a:ext>
             </a:extLst>
           </p:cNvPr>
@@ -2357,7 +2358,7 @@
           <p:cNvPr id="5" name="Datumsplatzhalter 4">
             <a:extLst>
               <a:ext uri="{FF2B5EF4-FFF2-40B4-BE49-F238E27FC236}">
-                <a16:creationId xmlns:a16="http://schemas.microsoft.com/office/drawing/2014/main" id="{25BEE8DE-F54E-AAC4-D1DF-7C5616A60A5D}"/>
+                <a16:creationId xmlns:a16="http://schemas.microsoft.com/office/drawing/2014/main" id="{7C5198EC-EA4C-4543-8488-6C134FA98544}"/>
               </a:ext>
             </a:extLst>
           </p:cNvPr>
@@ -2373,7 +2374,7 @@
           <a:bodyPr/>
           <a:lstStyle/>
           <a:p>
-            <a:fld id="{83C4AB47-C71B-4E79-A3F3-AF6AEE09EA81}" type="datetimeFigureOut">
+            <a:fld id="{93B07367-803E-42B4-B6CC-0D4380B0C07C}" type="datetimeFigureOut">
               <a:rPr lang="de-DE" smtClean="0"/>
               <a:t>09.10.2026</a:t>
             </a:fld>
@@ -2386,7 +2387,7 @@
           <p:cNvPr id="6" name="Fußzeilenplatzhalter 5">
             <a:extLst>
               <a:ext uri="{FF2B5EF4-FFF2-40B4-BE49-F238E27FC236}">
-                <a16:creationId xmlns:a16="http://schemas.microsoft.com/office/drawing/2014/main" id="{1E60200A-3031-BC8E-6278-BCB7427D2AC8}"/>
+                <a16:creationId xmlns:a16="http://schemas.microsoft.com/office/drawing/2014/main" id="{8A6E6598-2CB6-0DD5-0AE0-27580237A662}"/>
               </a:ext>
             </a:extLst>
           </p:cNvPr>
@@ -2411,7 +2412,7 @@
           <p:cNvPr id="7" name="Foliennummernplatzhalter 6">
             <a:extLst>
               <a:ext uri="{FF2B5EF4-FFF2-40B4-BE49-F238E27FC236}">
-                <a16:creationId xmlns:a16="http://schemas.microsoft.com/office/drawing/2014/main" id="{45B60289-F3F0-C625-99AC-ADE350B2AF42}"/>
+                <a16:creationId xmlns:a16="http://schemas.microsoft.com/office/drawing/2014/main" id="{CD99CD49-5430-CB0A-84C8-7E1EB4A23F3E}"/>
               </a:ext>
             </a:extLst>
           </p:cNvPr>
@@ -2427,7 +2428,7 @@
           <a:bodyPr/>
           <a:lstStyle/>
           <a:p>
-            <a:fld id="{56D4D39F-CBD4-4DCF-99B0-4CB27C07A787}" type="slidenum">
+            <a:fld id="{510660EA-E3F0-4E01-81FF-9EE36D78EF1F}" type="slidenum">
               <a:rPr lang="de-DE" smtClean="0"/>
               <a:t>‹Nr.›</a:t>
             </a:fld>
@@ -2438,7 +2439,7 @@
     </p:spTree>
     <p:extLst>
       <p:ext uri="{BB962C8B-B14F-4D97-AF65-F5344CB8AC3E}">
-        <p14:creationId xmlns:p14="http://schemas.microsoft.com/office/powerpoint/2010/main" val="3952083128"/>
+        <p14:creationId xmlns:p14="http://schemas.microsoft.com/office/powerpoint/2010/main" val="1736675809"/>
       </p:ext>
     </p:extLst>
   </p:cSld>
@@ -2470,7 +2471,7 @@
           <p:cNvPr id="2" name="Titel 1">
             <a:extLst>
               <a:ext uri="{FF2B5EF4-FFF2-40B4-BE49-F238E27FC236}">
-                <a16:creationId xmlns:a16="http://schemas.microsoft.com/office/drawing/2014/main" id="{0A2AE7A2-23AE-212A-26FF-C2A0A075E30A}"/>
+                <a16:creationId xmlns:a16="http://schemas.microsoft.com/office/drawing/2014/main" id="{C3E75573-AE69-0C8F-53D0-8A1D81303C66}"/>
               </a:ext>
             </a:extLst>
           </p:cNvPr>
@@ -2507,7 +2508,7 @@
           <p:cNvPr id="3" name="Bildplatzhalter 2">
             <a:extLst>
               <a:ext uri="{FF2B5EF4-FFF2-40B4-BE49-F238E27FC236}">
-                <a16:creationId xmlns:a16="http://schemas.microsoft.com/office/drawing/2014/main" id="{510F917C-FBCA-78FA-06BF-6CDCEF3FA264}"/>
+                <a16:creationId xmlns:a16="http://schemas.microsoft.com/office/drawing/2014/main" id="{61679EE0-8004-7BD6-C3D1-A5684DD9571C}"/>
               </a:ext>
             </a:extLst>
           </p:cNvPr>
@@ -2574,7 +2575,7 @@
           <p:cNvPr id="4" name="Textplatzhalter 3">
             <a:extLst>
               <a:ext uri="{FF2B5EF4-FFF2-40B4-BE49-F238E27FC236}">
-                <a16:creationId xmlns:a16="http://schemas.microsoft.com/office/drawing/2014/main" id="{7A3C7EE0-92AE-21E1-C053-4D43CDE0E34F}"/>
+                <a16:creationId xmlns:a16="http://schemas.microsoft.com/office/drawing/2014/main" id="{2A02676A-1FEE-19CB-EAC3-E2A74CD02E2D}"/>
               </a:ext>
             </a:extLst>
           </p:cNvPr>
@@ -2645,7 +2646,7 @@
           <p:cNvPr id="5" name="Datumsplatzhalter 4">
             <a:extLst>
               <a:ext uri="{FF2B5EF4-FFF2-40B4-BE49-F238E27FC236}">
-                <a16:creationId xmlns:a16="http://schemas.microsoft.com/office/drawing/2014/main" id="{578191EB-8EF5-774F-588D-7B6C5B9CCCFE}"/>
+                <a16:creationId xmlns:a16="http://schemas.microsoft.com/office/drawing/2014/main" id="{4A49ADA2-258D-C72B-0E8F-D0E0573FBA18}"/>
               </a:ext>
             </a:extLst>
           </p:cNvPr>
@@ -2661,7 +2662,7 @@
           <a:bodyPr/>
           <a:lstStyle/>
           <a:p>
-            <a:fld id="{83C4AB47-C71B-4E79-A3F3-AF6AEE09EA81}" type="datetimeFigureOut">
+            <a:fld id="{93B07367-803E-42B4-B6CC-0D4380B0C07C}" type="datetimeFigureOut">
               <a:rPr lang="de-DE" smtClean="0"/>
               <a:t>09.10.2026</a:t>
             </a:fld>
@@ -2674,7 +2675,7 @@
           <p:cNvPr id="6" name="Fußzeilenplatzhalter 5">
             <a:extLst>
               <a:ext uri="{FF2B5EF4-FFF2-40B4-BE49-F238E27FC236}">
-                <a16:creationId xmlns:a16="http://schemas.microsoft.com/office/drawing/2014/main" id="{9336E7DE-2698-1014-7A24-A87AC3CC42E1}"/>
+                <a16:creationId xmlns:a16="http://schemas.microsoft.com/office/drawing/2014/main" id="{775BE820-127B-6E36-E439-CA95D45D1E3B}"/>
               </a:ext>
             </a:extLst>
           </p:cNvPr>
@@ -2699,7 +2700,7 @@
           <p:cNvPr id="7" name="Foliennummernplatzhalter 6">
             <a:extLst>
               <a:ext uri="{FF2B5EF4-FFF2-40B4-BE49-F238E27FC236}">
-                <a16:creationId xmlns:a16="http://schemas.microsoft.com/office/drawing/2014/main" id="{A60F6CD2-BFB3-E7FC-9F62-37DA6626793B}"/>
+                <a16:creationId xmlns:a16="http://schemas.microsoft.com/office/drawing/2014/main" id="{6632D1ED-7D9C-0290-E7FE-B4DC65889EBF}"/>
               </a:ext>
             </a:extLst>
           </p:cNvPr>
@@ -2715,7 +2716,7 @@
           <a:bodyPr/>
           <a:lstStyle/>
           <a:p>
-            <a:fld id="{56D4D39F-CBD4-4DCF-99B0-4CB27C07A787}" type="slidenum">
+            <a:fld id="{510660EA-E3F0-4E01-81FF-9EE36D78EF1F}" type="slidenum">
               <a:rPr lang="de-DE" smtClean="0"/>
               <a:t>‹Nr.›</a:t>
             </a:fld>
@@ -2726,7 +2727,7 @@
     </p:spTree>
     <p:extLst>
       <p:ext uri="{BB962C8B-B14F-4D97-AF65-F5344CB8AC3E}">
-        <p14:creationId xmlns:p14="http://schemas.microsoft.com/office/powerpoint/2010/main" val="981653312"/>
+        <p14:creationId xmlns:p14="http://schemas.microsoft.com/office/powerpoint/2010/main" val="12431840"/>
       </p:ext>
     </p:extLst>
   </p:cSld>
@@ -2763,7 +2764,7 @@
           <p:cNvPr id="2" name="Titelplatzhalter 1">
             <a:extLst>
               <a:ext uri="{FF2B5EF4-FFF2-40B4-BE49-F238E27FC236}">
-                <a16:creationId xmlns:a16="http://schemas.microsoft.com/office/drawing/2014/main" id="{E26B0C57-960D-8B6F-7F91-A5B712142267}"/>
+                <a16:creationId xmlns:a16="http://schemas.microsoft.com/office/drawing/2014/main" id="{AF6A45A9-EB96-3520-99A9-A89DE705205F}"/>
               </a:ext>
             </a:extLst>
           </p:cNvPr>
@@ -2801,7 +2802,7 @@
           <p:cNvPr id="3" name="Textplatzhalter 2">
             <a:extLst>
               <a:ext uri="{FF2B5EF4-FFF2-40B4-BE49-F238E27FC236}">
-                <a16:creationId xmlns:a16="http://schemas.microsoft.com/office/drawing/2014/main" id="{B527C50B-1D99-3C93-1FDB-88185356F1E5}"/>
+                <a16:creationId xmlns:a16="http://schemas.microsoft.com/office/drawing/2014/main" id="{76CFDE62-CC9C-F2D5-D939-5AF1ACCF7DB5}"/>
               </a:ext>
             </a:extLst>
           </p:cNvPr>
@@ -2868,7 +2869,7 @@
           <p:cNvPr id="4" name="Datumsplatzhalter 3">
             <a:extLst>
               <a:ext uri="{FF2B5EF4-FFF2-40B4-BE49-F238E27FC236}">
-                <a16:creationId xmlns:a16="http://schemas.microsoft.com/office/drawing/2014/main" id="{618DA0E3-511E-0876-A4CD-F03697F5407B}"/>
+                <a16:creationId xmlns:a16="http://schemas.microsoft.com/office/drawing/2014/main" id="{139ED01D-25BD-AA55-179D-C9B3E0CBA236}"/>
               </a:ext>
             </a:extLst>
           </p:cNvPr>
@@ -2902,7 +2903,7 @@
             </a:lvl1pPr>
           </a:lstStyle>
           <a:p>
-            <a:fld id="{83C4AB47-C71B-4E79-A3F3-AF6AEE09EA81}" type="datetimeFigureOut">
+            <a:fld id="{93B07367-803E-42B4-B6CC-0D4380B0C07C}" type="datetimeFigureOut">
               <a:rPr lang="de-DE" smtClean="0"/>
               <a:t>09.10.2026</a:t>
             </a:fld>
@@ -2915,7 +2916,7 @@
           <p:cNvPr id="5" name="Fußzeilenplatzhalter 4">
             <a:extLst>
               <a:ext uri="{FF2B5EF4-FFF2-40B4-BE49-F238E27FC236}">
-                <a16:creationId xmlns:a16="http://schemas.microsoft.com/office/drawing/2014/main" id="{2A50062D-5D59-772B-F8E9-A59EF80A4449}"/>
+                <a16:creationId xmlns:a16="http://schemas.microsoft.com/office/drawing/2014/main" id="{D13A5E67-0588-9324-872E-B1D7F0D636A6}"/>
               </a:ext>
             </a:extLst>
           </p:cNvPr>
@@ -2958,7 +2959,7 @@
           <p:cNvPr id="6" name="Foliennummernplatzhalter 5">
             <a:extLst>
               <a:ext uri="{FF2B5EF4-FFF2-40B4-BE49-F238E27FC236}">
-                <a16:creationId xmlns:a16="http://schemas.microsoft.com/office/drawing/2014/main" id="{0C82D94F-7819-9A3E-ED16-D845774FA318}"/>
+                <a16:creationId xmlns:a16="http://schemas.microsoft.com/office/drawing/2014/main" id="{71932D27-3930-9FA2-717A-EC205A84B4A2}"/>
               </a:ext>
             </a:extLst>
           </p:cNvPr>
@@ -2992,7 +2993,7 @@
             </a:lvl1pPr>
           </a:lstStyle>
           <a:p>
-            <a:fld id="{56D4D39F-CBD4-4DCF-99B0-4CB27C07A787}" type="slidenum">
+            <a:fld id="{510660EA-E3F0-4E01-81FF-9EE36D78EF1F}" type="slidenum">
               <a:rPr lang="de-DE" smtClean="0"/>
               <a:t>‹Nr.›</a:t>
             </a:fld>
@@ -3003,7 +3004,7 @@
     </p:spTree>
     <p:extLst>
       <p:ext uri="{BB962C8B-B14F-4D97-AF65-F5344CB8AC3E}">
-        <p14:creationId xmlns:p14="http://schemas.microsoft.com/office/powerpoint/2010/main" val="577984564"/>
+        <p14:creationId xmlns:p14="http://schemas.microsoft.com/office/powerpoint/2010/main" val="1438925076"/>
       </p:ext>
     </p:extLst>
   </p:cSld>
@@ -3326,7 +3327,7 @@
           <p:cNvPr id="2" name="Tabelle 1">
             <a:extLst>
               <a:ext uri="{FF2B5EF4-FFF2-40B4-BE49-F238E27FC236}">
-                <a16:creationId xmlns:a16="http://schemas.microsoft.com/office/drawing/2014/main" id="{96754B73-F7C0-0CED-1188-3A93BA80E1ED}"/>
+                <a16:creationId xmlns:a16="http://schemas.microsoft.com/office/drawing/2014/main" id="{0956BCC4-4376-FDE2-8FB9-F766B1420E7E}"/>
               </a:ext>
             </a:extLst>
           </p:cNvPr>
@@ -3336,7 +3337,7 @@
           <p:nvPr>
             <p:extLst>
               <p:ext uri="{D42A27DB-BD31-4B8C-83A1-F6EECF244321}">
-                <p14:modId xmlns:p14="http://schemas.microsoft.com/office/powerpoint/2010/main" val="304697722"/>
+                <p14:modId xmlns:p14="http://schemas.microsoft.com/office/powerpoint/2010/main" val="117909759"/>
               </p:ext>
             </p:extLst>
           </p:nvPr>
@@ -3355,21 +3356,21 @@
                 <a:gridCol w="1820333">
                   <a:extLst>
                     <a:ext uri="{9D8B030D-6E8A-4147-A177-3AD203B41FA5}">
-                      <a16:colId xmlns:a16="http://schemas.microsoft.com/office/drawing/2014/main" val="3754852967"/>
+                      <a16:colId xmlns:a16="http://schemas.microsoft.com/office/drawing/2014/main" val="3192126885"/>
                     </a:ext>
                   </a:extLst>
                 </a:gridCol>
                 <a:gridCol w="1820333">
                   <a:extLst>
                     <a:ext uri="{9D8B030D-6E8A-4147-A177-3AD203B41FA5}">
-                      <a16:colId xmlns:a16="http://schemas.microsoft.com/office/drawing/2014/main" val="2874283175"/>
+                      <a16:colId xmlns:a16="http://schemas.microsoft.com/office/drawing/2014/main" val="2157036526"/>
                     </a:ext>
                   </a:extLst>
                 </a:gridCol>
                 <a:gridCol w="1820333">
                   <a:extLst>
                     <a:ext uri="{9D8B030D-6E8A-4147-A177-3AD203B41FA5}">
-                      <a16:colId xmlns:a16="http://schemas.microsoft.com/office/drawing/2014/main" val="2542442588"/>
+                      <a16:colId xmlns:a16="http://schemas.microsoft.com/office/drawing/2014/main" val="3620055875"/>
                     </a:ext>
                   </a:extLst>
                 </a:gridCol>
@@ -3431,7 +3432,7 @@
                 </a:tc>
                 <a:extLst>
                   <a:ext uri="{0D108BD9-81ED-4DB2-BD59-A6C34878D82A}">
-                    <a16:rowId xmlns:a16="http://schemas.microsoft.com/office/drawing/2014/main" val="297934735"/>
+                    <a16:rowId xmlns:a16="http://schemas.microsoft.com/office/drawing/2014/main" val="2941139661"/>
                   </a:ext>
                 </a:extLst>
               </a:tr>
@@ -3492,7 +3493,7 @@
                 </a:tc>
                 <a:extLst>
                   <a:ext uri="{0D108BD9-81ED-4DB2-BD59-A6C34878D82A}">
-                    <a16:rowId xmlns:a16="http://schemas.microsoft.com/office/drawing/2014/main" val="662530377"/>
+                    <a16:rowId xmlns:a16="http://schemas.microsoft.com/office/drawing/2014/main" val="3703092018"/>
                   </a:ext>
                 </a:extLst>
               </a:tr>
@@ -3553,7 +3554,7 @@
                 </a:tc>
                 <a:extLst>
                   <a:ext uri="{0D108BD9-81ED-4DB2-BD59-A6C34878D82A}">
-                    <a16:rowId xmlns:a16="http://schemas.microsoft.com/office/drawing/2014/main" val="1166971990"/>
+                    <a16:rowId xmlns:a16="http://schemas.microsoft.com/office/drawing/2014/main" val="3033656952"/>
                   </a:ext>
                 </a:extLst>
               </a:tr>
@@ -3566,7 +3567,7 @@
           <p:cNvPr id="3" name="Tabelle 2">
             <a:extLst>
               <a:ext uri="{FF2B5EF4-FFF2-40B4-BE49-F238E27FC236}">
-                <a16:creationId xmlns:a16="http://schemas.microsoft.com/office/drawing/2014/main" id="{C833EAD3-82AB-BF7C-EF27-223C7F95AE6F}"/>
+                <a16:creationId xmlns:a16="http://schemas.microsoft.com/office/drawing/2014/main" id="{D2641AD9-17BD-6092-B2FF-1B3FB6D0553C}"/>
               </a:ext>
             </a:extLst>
           </p:cNvPr>
@@ -3576,7 +3577,7 @@
           <p:nvPr>
             <p:extLst>
               <p:ext uri="{D42A27DB-BD31-4B8C-83A1-F6EECF244321}">
-                <p14:modId xmlns:p14="http://schemas.microsoft.com/office/powerpoint/2010/main" val="2071880851"/>
+                <p14:modId xmlns:p14="http://schemas.microsoft.com/office/powerpoint/2010/main" val="2604617980"/>
               </p:ext>
             </p:extLst>
           </p:nvPr>
@@ -3595,21 +3596,21 @@
                 <a:gridCol w="1820333">
                   <a:extLst>
                     <a:ext uri="{9D8B030D-6E8A-4147-A177-3AD203B41FA5}">
-                      <a16:colId xmlns:a16="http://schemas.microsoft.com/office/drawing/2014/main" val="1593486946"/>
+                      <a16:colId xmlns:a16="http://schemas.microsoft.com/office/drawing/2014/main" val="3313508852"/>
                     </a:ext>
                   </a:extLst>
                 </a:gridCol>
                 <a:gridCol w="1820333">
                   <a:extLst>
                     <a:ext uri="{9D8B030D-6E8A-4147-A177-3AD203B41FA5}">
-                      <a16:colId xmlns:a16="http://schemas.microsoft.com/office/drawing/2014/main" val="2328280625"/>
+                      <a16:colId xmlns:a16="http://schemas.microsoft.com/office/drawing/2014/main" val="3309016035"/>
                     </a:ext>
                   </a:extLst>
                 </a:gridCol>
                 <a:gridCol w="1820333">
                   <a:extLst>
                     <a:ext uri="{9D8B030D-6E8A-4147-A177-3AD203B41FA5}">
-                      <a16:colId xmlns:a16="http://schemas.microsoft.com/office/drawing/2014/main" val="563595077"/>
+                      <a16:colId xmlns:a16="http://schemas.microsoft.com/office/drawing/2014/main" val="4054238538"/>
                     </a:ext>
                   </a:extLst>
                 </a:gridCol>
@@ -3671,7 +3672,7 @@
                 </a:tc>
                 <a:extLst>
                   <a:ext uri="{0D108BD9-81ED-4DB2-BD59-A6C34878D82A}">
-                    <a16:rowId xmlns:a16="http://schemas.microsoft.com/office/drawing/2014/main" val="942270289"/>
+                    <a16:rowId xmlns:a16="http://schemas.microsoft.com/office/drawing/2014/main" val="1641413675"/>
                   </a:ext>
                 </a:extLst>
               </a:tr>
@@ -3732,7 +3733,7 @@
                 </a:tc>
                 <a:extLst>
                   <a:ext uri="{0D108BD9-81ED-4DB2-BD59-A6C34878D82A}">
-                    <a16:rowId xmlns:a16="http://schemas.microsoft.com/office/drawing/2014/main" val="3200149522"/>
+                    <a16:rowId xmlns:a16="http://schemas.microsoft.com/office/drawing/2014/main" val="3851160118"/>
                   </a:ext>
                 </a:extLst>
               </a:tr>
@@ -3793,7 +3794,7 @@
                 </a:tc>
                 <a:extLst>
                   <a:ext uri="{0D108BD9-81ED-4DB2-BD59-A6C34878D82A}">
-                    <a16:rowId xmlns:a16="http://schemas.microsoft.com/office/drawing/2014/main" val="1016619926"/>
+                    <a16:rowId xmlns:a16="http://schemas.microsoft.com/office/drawing/2014/main" val="319513160"/>
                   </a:ext>
                 </a:extLst>
               </a:tr>
@@ -3806,7 +3807,7 @@
           <p:cNvPr id="4" name="Tabelle 3">
             <a:extLst>
               <a:ext uri="{FF2B5EF4-FFF2-40B4-BE49-F238E27FC236}">
-                <a16:creationId xmlns:a16="http://schemas.microsoft.com/office/drawing/2014/main" id="{68177D57-608B-CB90-4067-6A5AB9A1F935}"/>
+                <a16:creationId xmlns:a16="http://schemas.microsoft.com/office/drawing/2014/main" id="{6B2EF2B2-94D6-F422-9F06-00C14AA21AEB}"/>
               </a:ext>
             </a:extLst>
           </p:cNvPr>
@@ -3816,7 +3817,7 @@
           <p:nvPr>
             <p:extLst>
               <p:ext uri="{D42A27DB-BD31-4B8C-83A1-F6EECF244321}">
-                <p14:modId xmlns:p14="http://schemas.microsoft.com/office/powerpoint/2010/main" val="486969024"/>
+                <p14:modId xmlns:p14="http://schemas.microsoft.com/office/powerpoint/2010/main" val="758142749"/>
               </p:ext>
             </p:extLst>
           </p:nvPr>
@@ -3835,21 +3836,21 @@
                 <a:gridCol w="1820333">
                   <a:extLst>
                     <a:ext uri="{9D8B030D-6E8A-4147-A177-3AD203B41FA5}">
-                      <a16:colId xmlns:a16="http://schemas.microsoft.com/office/drawing/2014/main" val="2120644120"/>
+                      <a16:colId xmlns:a16="http://schemas.microsoft.com/office/drawing/2014/main" val="1459348167"/>
                     </a:ext>
                   </a:extLst>
                 </a:gridCol>
                 <a:gridCol w="1820333">
                   <a:extLst>
                     <a:ext uri="{9D8B030D-6E8A-4147-A177-3AD203B41FA5}">
-                      <a16:colId xmlns:a16="http://schemas.microsoft.com/office/drawing/2014/main" val="3315742901"/>
+                      <a16:colId xmlns:a16="http://schemas.microsoft.com/office/drawing/2014/main" val="1222138527"/>
                     </a:ext>
                   </a:extLst>
                 </a:gridCol>
                 <a:gridCol w="1820333">
                   <a:extLst>
                     <a:ext uri="{9D8B030D-6E8A-4147-A177-3AD203B41FA5}">
-                      <a16:colId xmlns:a16="http://schemas.microsoft.com/office/drawing/2014/main" val="4104258830"/>
+                      <a16:colId xmlns:a16="http://schemas.microsoft.com/office/drawing/2014/main" val="816044769"/>
                     </a:ext>
                   </a:extLst>
                 </a:gridCol>
@@ -3911,7 +3912,7 @@
                 </a:tc>
                 <a:extLst>
                   <a:ext uri="{0D108BD9-81ED-4DB2-BD59-A6C34878D82A}">
-                    <a16:rowId xmlns:a16="http://schemas.microsoft.com/office/drawing/2014/main" val="1469179412"/>
+                    <a16:rowId xmlns:a16="http://schemas.microsoft.com/office/drawing/2014/main" val="3691517283"/>
                   </a:ext>
                 </a:extLst>
               </a:tr>
@@ -3972,7 +3973,7 @@
                 </a:tc>
                 <a:extLst>
                   <a:ext uri="{0D108BD9-81ED-4DB2-BD59-A6C34878D82A}">
-                    <a16:rowId xmlns:a16="http://schemas.microsoft.com/office/drawing/2014/main" val="2184146601"/>
+                    <a16:rowId xmlns:a16="http://schemas.microsoft.com/office/drawing/2014/main" val="1582096929"/>
                   </a:ext>
                 </a:extLst>
               </a:tr>
@@ -4033,7 +4034,7 @@
                 </a:tc>
                 <a:extLst>
                   <a:ext uri="{0D108BD9-81ED-4DB2-BD59-A6C34878D82A}">
-                    <a16:rowId xmlns:a16="http://schemas.microsoft.com/office/drawing/2014/main" val="525487350"/>
+                    <a16:rowId xmlns:a16="http://schemas.microsoft.com/office/drawing/2014/main" val="180094524"/>
                   </a:ext>
                 </a:extLst>
               </a:tr>
@@ -4046,7 +4047,7 @@
           <p:cNvPr id="5" name="Tabelle 4">
             <a:extLst>
               <a:ext uri="{FF2B5EF4-FFF2-40B4-BE49-F238E27FC236}">
-                <a16:creationId xmlns:a16="http://schemas.microsoft.com/office/drawing/2014/main" id="{D34EE75B-B2FC-3AC8-D1A0-C579B5999F2D}"/>
+                <a16:creationId xmlns:a16="http://schemas.microsoft.com/office/drawing/2014/main" id="{0BD4AD60-396A-A9A1-F7B8-1359720B221F}"/>
               </a:ext>
             </a:extLst>
           </p:cNvPr>
@@ -4056,7 +4057,7 @@
           <p:nvPr>
             <p:extLst>
               <p:ext uri="{D42A27DB-BD31-4B8C-83A1-F6EECF244321}">
-                <p14:modId xmlns:p14="http://schemas.microsoft.com/office/powerpoint/2010/main" val="1801707053"/>
+                <p14:modId xmlns:p14="http://schemas.microsoft.com/office/powerpoint/2010/main" val="1363756805"/>
               </p:ext>
             </p:extLst>
           </p:nvPr>
@@ -4075,21 +4076,21 @@
                 <a:gridCol w="1820333">
                   <a:extLst>
                     <a:ext uri="{9D8B030D-6E8A-4147-A177-3AD203B41FA5}">
-                      <a16:colId xmlns:a16="http://schemas.microsoft.com/office/drawing/2014/main" val="3296732037"/>
+                      <a16:colId xmlns:a16="http://schemas.microsoft.com/office/drawing/2014/main" val="2712725592"/>
                     </a:ext>
                   </a:extLst>
                 </a:gridCol>
                 <a:gridCol w="1820333">
                   <a:extLst>
                     <a:ext uri="{9D8B030D-6E8A-4147-A177-3AD203B41FA5}">
-                      <a16:colId xmlns:a16="http://schemas.microsoft.com/office/drawing/2014/main" val="1154004027"/>
+                      <a16:colId xmlns:a16="http://schemas.microsoft.com/office/drawing/2014/main" val="898104265"/>
                     </a:ext>
                   </a:extLst>
                 </a:gridCol>
                 <a:gridCol w="1820333">
                   <a:extLst>
                     <a:ext uri="{9D8B030D-6E8A-4147-A177-3AD203B41FA5}">
-                      <a16:colId xmlns:a16="http://schemas.microsoft.com/office/drawing/2014/main" val="4159456102"/>
+                      <a16:colId xmlns:a16="http://schemas.microsoft.com/office/drawing/2014/main" val="2078785529"/>
                     </a:ext>
                   </a:extLst>
                 </a:gridCol>
@@ -4141,7 +4142,7 @@
                 </a:tc>
                 <a:extLst>
                   <a:ext uri="{0D108BD9-81ED-4DB2-BD59-A6C34878D82A}">
-                    <a16:rowId xmlns:a16="http://schemas.microsoft.com/office/drawing/2014/main" val="593560576"/>
+                    <a16:rowId xmlns:a16="http://schemas.microsoft.com/office/drawing/2014/main" val="2633092198"/>
                   </a:ext>
                 </a:extLst>
               </a:tr>
@@ -4192,7 +4193,7 @@
                 </a:tc>
                 <a:extLst>
                   <a:ext uri="{0D108BD9-81ED-4DB2-BD59-A6C34878D82A}">
-                    <a16:rowId xmlns:a16="http://schemas.microsoft.com/office/drawing/2014/main" val="3677066051"/>
+                    <a16:rowId xmlns:a16="http://schemas.microsoft.com/office/drawing/2014/main" val="793822527"/>
                   </a:ext>
                 </a:extLst>
               </a:tr>
@@ -4238,7 +4239,7 @@
                 </a:tc>
                 <a:extLst>
                   <a:ext uri="{0D108BD9-81ED-4DB2-BD59-A6C34878D82A}">
-                    <a16:rowId xmlns:a16="http://schemas.microsoft.com/office/drawing/2014/main" val="2590595271"/>
+                    <a16:rowId xmlns:a16="http://schemas.microsoft.com/office/drawing/2014/main" val="3815726123"/>
                   </a:ext>
                 </a:extLst>
               </a:tr>
@@ -4249,7 +4250,1207 @@
     </p:spTree>
     <p:extLst>
       <p:ext uri="{BB962C8B-B14F-4D97-AF65-F5344CB8AC3E}">
-        <p14:creationId xmlns:p14="http://schemas.microsoft.com/office/powerpoint/2010/main" val="2340809429"/>
+        <p14:creationId xmlns:p14="http://schemas.microsoft.com/office/powerpoint/2010/main" val="547081645"/>
+      </p:ext>
+    </p:extLst>
+  </p:cSld>
+  <p:clrMapOvr>
+    <a:masterClrMapping/>
+  </p:clrMapOvr>
+</p:sld>
+</file>
+
+<file path=ppt/slides/slide2.xml><?xml version="1.0" encoding="utf-8"?>
+<p:sld xmlns:a="http://schemas.openxmlformats.org/drawingml/2006/main" xmlns:r="http://schemas.openxmlformats.org/officeDocument/2006/relationships" xmlns:p="http://schemas.openxmlformats.org/presentationml/2006/main">
+  <p:cSld>
+    <p:spTree>
+      <p:nvGrpSpPr>
+        <p:cNvPr id="1" name=""/>
+        <p:cNvGrpSpPr/>
+        <p:nvPr/>
+      </p:nvGrpSpPr>
+      <p:grpSpPr>
+        <a:xfrm>
+          <a:off x="0" y="0"/>
+          <a:ext cx="0" cy="0"/>
+          <a:chOff x="0" y="0"/>
+          <a:chExt cx="0" cy="0"/>
+        </a:xfrm>
+      </p:grpSpPr>
+      <p:graphicFrame>
+        <p:nvGraphicFramePr>
+          <p:cNvPr id="2" name="Tabelle 1">
+            <a:extLst>
+              <a:ext uri="{FF2B5EF4-FFF2-40B4-BE49-F238E27FC236}">
+                <a16:creationId xmlns:a16="http://schemas.microsoft.com/office/drawing/2014/main" id="{C0002ABB-5E07-AC42-EEE2-D3167B3EF8F4}"/>
+              </a:ext>
+            </a:extLst>
+          </p:cNvPr>
+          <p:cNvGraphicFramePr>
+            <a:graphicFrameLocks noGrp="1"/>
+          </p:cNvGraphicFramePr>
+          <p:nvPr>
+            <p:extLst>
+              <p:ext uri="{D42A27DB-BD31-4B8C-83A1-F6EECF244321}">
+                <p14:modId xmlns:p14="http://schemas.microsoft.com/office/powerpoint/2010/main" val="2438337786"/>
+              </p:ext>
+            </p:extLst>
+          </p:nvPr>
+        </p:nvGraphicFramePr>
+        <p:xfrm>
+          <a:off x="381000" y="381000"/>
+          <a:ext cx="3683000" cy="2540000"/>
+        </p:xfrm>
+        <a:graphic>
+          <a:graphicData uri="http://schemas.openxmlformats.org/drawingml/2006/table">
+            <a:tbl>
+              <a:tblPr firstRow="1" bandRow="1">
+                <a:tableStyleId>{5C22544A-7EE6-4342-B048-85BDC9FD1C3A}</a:tableStyleId>
+              </a:tblPr>
+              <a:tblGrid>
+                <a:gridCol w="1227667">
+                  <a:extLst>
+                    <a:ext uri="{9D8B030D-6E8A-4147-A177-3AD203B41FA5}">
+                      <a16:colId xmlns:a16="http://schemas.microsoft.com/office/drawing/2014/main" val="762874539"/>
+                    </a:ext>
+                  </a:extLst>
+                </a:gridCol>
+                <a:gridCol w="1227667">
+                  <a:extLst>
+                    <a:ext uri="{9D8B030D-6E8A-4147-A177-3AD203B41FA5}">
+                      <a16:colId xmlns:a16="http://schemas.microsoft.com/office/drawing/2014/main" val="926455068"/>
+                    </a:ext>
+                  </a:extLst>
+                </a:gridCol>
+                <a:gridCol w="1227667">
+                  <a:extLst>
+                    <a:ext uri="{9D8B030D-6E8A-4147-A177-3AD203B41FA5}">
+                      <a16:colId xmlns:a16="http://schemas.microsoft.com/office/drawing/2014/main" val="1283763815"/>
+                    </a:ext>
+                  </a:extLst>
+                </a:gridCol>
+              </a:tblGrid>
+              <a:tr h="846667">
+                <a:tc>
+                  <a:txBody>
+                    <a:bodyPr/>
+                    <a:lstStyle/>
+                    <a:p>
+                      <a:r>
+                        <a:rPr lang="de-DE"/>
+                        <a:t>R1C1</a:t>
+                      </a:r>
+                    </a:p>
+                  </a:txBody>
+                  <a:tcPr/>
+                </a:tc>
+                <a:tc>
+                  <a:txBody>
+                    <a:bodyPr/>
+                    <a:lstStyle/>
+                    <a:p>
+                      <a:r>
+                        <a:rPr lang="de-DE"/>
+                        <a:t>R1C2</a:t>
+                      </a:r>
+                    </a:p>
+                  </a:txBody>
+                  <a:tcPr/>
+                </a:tc>
+                <a:tc>
+                  <a:txBody>
+                    <a:bodyPr/>
+                    <a:lstStyle/>
+                    <a:p>
+                      <a:r>
+                        <a:rPr lang="de-DE"/>
+                        <a:t>R1C3</a:t>
+                      </a:r>
+                    </a:p>
+                  </a:txBody>
+                  <a:tcPr/>
+                </a:tc>
+                <a:extLst>
+                  <a:ext uri="{0D108BD9-81ED-4DB2-BD59-A6C34878D82A}">
+                    <a16:rowId xmlns:a16="http://schemas.microsoft.com/office/drawing/2014/main" val="815481988"/>
+                  </a:ext>
+                </a:extLst>
+              </a:tr>
+              <a:tr h="846667">
+                <a:tc>
+                  <a:txBody>
+                    <a:bodyPr/>
+                    <a:lstStyle/>
+                    <a:p>
+                      <a:r>
+                        <a:rPr lang="de-DE"/>
+                        <a:t>R2C1</a:t>
+                      </a:r>
+                    </a:p>
+                  </a:txBody>
+                  <a:tcPr/>
+                </a:tc>
+                <a:tc>
+                  <a:txBody>
+                    <a:bodyPr/>
+                    <a:lstStyle/>
+                    <a:p>
+                      <a:r>
+                        <a:rPr lang="de-DE"/>
+                        <a:t>R2C2</a:t>
+                      </a:r>
+                    </a:p>
+                  </a:txBody>
+                  <a:tcPr/>
+                </a:tc>
+                <a:tc>
+                  <a:txBody>
+                    <a:bodyPr/>
+                    <a:lstStyle/>
+                    <a:p>
+                      <a:r>
+                        <a:rPr lang="de-DE"/>
+                        <a:t>R2C3</a:t>
+                      </a:r>
+                    </a:p>
+                  </a:txBody>
+                  <a:tcPr/>
+                </a:tc>
+                <a:extLst>
+                  <a:ext uri="{0D108BD9-81ED-4DB2-BD59-A6C34878D82A}">
+                    <a16:rowId xmlns:a16="http://schemas.microsoft.com/office/drawing/2014/main" val="1129354357"/>
+                  </a:ext>
+                </a:extLst>
+              </a:tr>
+              <a:tr h="846667">
+                <a:tc>
+                  <a:txBody>
+                    <a:bodyPr/>
+                    <a:lstStyle/>
+                    <a:p>
+                      <a:r>
+                        <a:rPr lang="de-DE"/>
+                        <a:t>R3C1</a:t>
+                      </a:r>
+                    </a:p>
+                  </a:txBody>
+                  <a:tcPr/>
+                </a:tc>
+                <a:tc>
+                  <a:txBody>
+                    <a:bodyPr/>
+                    <a:lstStyle/>
+                    <a:p>
+                      <a:r>
+                        <a:rPr lang="de-DE"/>
+                        <a:t>R3C2</a:t>
+                      </a:r>
+                    </a:p>
+                  </a:txBody>
+                  <a:tcPr/>
+                </a:tc>
+                <a:tc>
+                  <a:txBody>
+                    <a:bodyPr/>
+                    <a:lstStyle/>
+                    <a:p>
+                      <a:r>
+                        <a:rPr lang="de-DE"/>
+                        <a:t>R3C3</a:t>
+                      </a:r>
+                    </a:p>
+                  </a:txBody>
+                  <a:tcPr/>
+                </a:tc>
+                <a:extLst>
+                  <a:ext uri="{0D108BD9-81ED-4DB2-BD59-A6C34878D82A}">
+                    <a16:rowId xmlns:a16="http://schemas.microsoft.com/office/drawing/2014/main" val="3524691844"/>
+                  </a:ext>
+                </a:extLst>
+              </a:tr>
+            </a:tbl>
+          </a:graphicData>
+        </a:graphic>
+      </p:graphicFrame>
+      <p:graphicFrame>
+        <p:nvGraphicFramePr>
+          <p:cNvPr id="3" name="Tabelle 2">
+            <a:extLst>
+              <a:ext uri="{FF2B5EF4-FFF2-40B4-BE49-F238E27FC236}">
+                <a16:creationId xmlns:a16="http://schemas.microsoft.com/office/drawing/2014/main" id="{78A0C8AA-1486-3B88-1AAE-D80252231602}"/>
+              </a:ext>
+            </a:extLst>
+          </p:cNvPr>
+          <p:cNvGraphicFramePr>
+            <a:graphicFrameLocks noGrp="1"/>
+          </p:cNvGraphicFramePr>
+          <p:nvPr>
+            <p:extLst>
+              <p:ext uri="{D42A27DB-BD31-4B8C-83A1-F6EECF244321}">
+                <p14:modId xmlns:p14="http://schemas.microsoft.com/office/powerpoint/2010/main" val="1952006438"/>
+              </p:ext>
+            </p:extLst>
+          </p:nvPr>
+        </p:nvGraphicFramePr>
+        <p:xfrm>
+          <a:off x="4318000" y="381000"/>
+          <a:ext cx="3683000" cy="2540000"/>
+        </p:xfrm>
+        <a:graphic>
+          <a:graphicData uri="http://schemas.openxmlformats.org/drawingml/2006/table">
+            <a:tbl>
+              <a:tblPr firstRow="1" bandRow="1">
+                <a:tableStyleId>{0E3FDE45-AF77-4B5C-9715-49D594BDF05E}</a:tableStyleId>
+              </a:tblPr>
+              <a:tblGrid>
+                <a:gridCol w="1227667">
+                  <a:extLst>
+                    <a:ext uri="{9D8B030D-6E8A-4147-A177-3AD203B41FA5}">
+                      <a16:colId xmlns:a16="http://schemas.microsoft.com/office/drawing/2014/main" val="615824191"/>
+                    </a:ext>
+                  </a:extLst>
+                </a:gridCol>
+                <a:gridCol w="1227667">
+                  <a:extLst>
+                    <a:ext uri="{9D8B030D-6E8A-4147-A177-3AD203B41FA5}">
+                      <a16:colId xmlns:a16="http://schemas.microsoft.com/office/drawing/2014/main" val="3441084755"/>
+                    </a:ext>
+                  </a:extLst>
+                </a:gridCol>
+                <a:gridCol w="1227667">
+                  <a:extLst>
+                    <a:ext uri="{9D8B030D-6E8A-4147-A177-3AD203B41FA5}">
+                      <a16:colId xmlns:a16="http://schemas.microsoft.com/office/drawing/2014/main" val="1556323081"/>
+                    </a:ext>
+                  </a:extLst>
+                </a:gridCol>
+              </a:tblGrid>
+              <a:tr h="846667">
+                <a:tc>
+                  <a:txBody>
+                    <a:bodyPr/>
+                    <a:lstStyle/>
+                    <a:p>
+                      <a:r>
+                        <a:rPr lang="de-DE"/>
+                        <a:t>R1C1</a:t>
+                      </a:r>
+                    </a:p>
+                  </a:txBody>
+                  <a:tcPr/>
+                </a:tc>
+                <a:tc>
+                  <a:txBody>
+                    <a:bodyPr/>
+                    <a:lstStyle/>
+                    <a:p>
+                      <a:r>
+                        <a:rPr lang="de-DE"/>
+                        <a:t>R1C2</a:t>
+                      </a:r>
+                    </a:p>
+                  </a:txBody>
+                  <a:tcPr/>
+                </a:tc>
+                <a:tc>
+                  <a:txBody>
+                    <a:bodyPr/>
+                    <a:lstStyle/>
+                    <a:p>
+                      <a:r>
+                        <a:rPr lang="de-DE"/>
+                        <a:t>R1C3</a:t>
+                      </a:r>
+                    </a:p>
+                  </a:txBody>
+                  <a:tcPr/>
+                </a:tc>
+                <a:extLst>
+                  <a:ext uri="{0D108BD9-81ED-4DB2-BD59-A6C34878D82A}">
+                    <a16:rowId xmlns:a16="http://schemas.microsoft.com/office/drawing/2014/main" val="819840424"/>
+                  </a:ext>
+                </a:extLst>
+              </a:tr>
+              <a:tr h="846667">
+                <a:tc>
+                  <a:txBody>
+                    <a:bodyPr/>
+                    <a:lstStyle/>
+                    <a:p>
+                      <a:r>
+                        <a:rPr lang="de-DE"/>
+                        <a:t>R2C1</a:t>
+                      </a:r>
+                    </a:p>
+                  </a:txBody>
+                  <a:tcPr/>
+                </a:tc>
+                <a:tc>
+                  <a:txBody>
+                    <a:bodyPr/>
+                    <a:lstStyle/>
+                    <a:p>
+                      <a:r>
+                        <a:rPr lang="de-DE"/>
+                        <a:t>R2C2</a:t>
+                      </a:r>
+                    </a:p>
+                  </a:txBody>
+                  <a:tcPr/>
+                </a:tc>
+                <a:tc>
+                  <a:txBody>
+                    <a:bodyPr/>
+                    <a:lstStyle/>
+                    <a:p>
+                      <a:r>
+                        <a:rPr lang="de-DE"/>
+                        <a:t>R2C3</a:t>
+                      </a:r>
+                    </a:p>
+                  </a:txBody>
+                  <a:tcPr/>
+                </a:tc>
+                <a:extLst>
+                  <a:ext uri="{0D108BD9-81ED-4DB2-BD59-A6C34878D82A}">
+                    <a16:rowId xmlns:a16="http://schemas.microsoft.com/office/drawing/2014/main" val="4227859561"/>
+                  </a:ext>
+                </a:extLst>
+              </a:tr>
+              <a:tr h="846667">
+                <a:tc>
+                  <a:txBody>
+                    <a:bodyPr/>
+                    <a:lstStyle/>
+                    <a:p>
+                      <a:r>
+                        <a:rPr lang="de-DE"/>
+                        <a:t>R3C1</a:t>
+                      </a:r>
+                    </a:p>
+                  </a:txBody>
+                  <a:tcPr/>
+                </a:tc>
+                <a:tc>
+                  <a:txBody>
+                    <a:bodyPr/>
+                    <a:lstStyle/>
+                    <a:p>
+                      <a:r>
+                        <a:rPr lang="de-DE"/>
+                        <a:t>R3C2</a:t>
+                      </a:r>
+                    </a:p>
+                  </a:txBody>
+                  <a:tcPr/>
+                </a:tc>
+                <a:tc>
+                  <a:txBody>
+                    <a:bodyPr/>
+                    <a:lstStyle/>
+                    <a:p>
+                      <a:r>
+                        <a:rPr lang="de-DE"/>
+                        <a:t>R3C3</a:t>
+                      </a:r>
+                    </a:p>
+                  </a:txBody>
+                  <a:tcPr/>
+                </a:tc>
+                <a:extLst>
+                  <a:ext uri="{0D108BD9-81ED-4DB2-BD59-A6C34878D82A}">
+                    <a16:rowId xmlns:a16="http://schemas.microsoft.com/office/drawing/2014/main" val="277732663"/>
+                  </a:ext>
+                </a:extLst>
+              </a:tr>
+            </a:tbl>
+          </a:graphicData>
+        </a:graphic>
+      </p:graphicFrame>
+      <p:graphicFrame>
+        <p:nvGraphicFramePr>
+          <p:cNvPr id="4" name="Tabelle 3">
+            <a:extLst>
+              <a:ext uri="{FF2B5EF4-FFF2-40B4-BE49-F238E27FC236}">
+                <a16:creationId xmlns:a16="http://schemas.microsoft.com/office/drawing/2014/main" id="{C42C2762-77DA-C73D-74F3-5DB7A39D3F2A}"/>
+              </a:ext>
+            </a:extLst>
+          </p:cNvPr>
+          <p:cNvGraphicFramePr>
+            <a:graphicFrameLocks noGrp="1"/>
+          </p:cNvGraphicFramePr>
+          <p:nvPr>
+            <p:extLst>
+              <p:ext uri="{D42A27DB-BD31-4B8C-83A1-F6EECF244321}">
+                <p14:modId xmlns:p14="http://schemas.microsoft.com/office/powerpoint/2010/main" val="2460604803"/>
+              </p:ext>
+            </p:extLst>
+          </p:nvPr>
+        </p:nvGraphicFramePr>
+        <p:xfrm>
+          <a:off x="8255000" y="381000"/>
+          <a:ext cx="3683000" cy="2540000"/>
+        </p:xfrm>
+        <a:graphic>
+          <a:graphicData uri="http://schemas.openxmlformats.org/drawingml/2006/table">
+            <a:tbl>
+              <a:tblPr firstRow="1" bandRow="1">
+                <a:tableStyleId>{E8034E78-7F5D-4C2E-B375-FC64B27BC917}</a:tableStyleId>
+              </a:tblPr>
+              <a:tblGrid>
+                <a:gridCol w="1227667">
+                  <a:extLst>
+                    <a:ext uri="{9D8B030D-6E8A-4147-A177-3AD203B41FA5}">
+                      <a16:colId xmlns:a16="http://schemas.microsoft.com/office/drawing/2014/main" val="1801476599"/>
+                    </a:ext>
+                  </a:extLst>
+                </a:gridCol>
+                <a:gridCol w="1227667">
+                  <a:extLst>
+                    <a:ext uri="{9D8B030D-6E8A-4147-A177-3AD203B41FA5}">
+                      <a16:colId xmlns:a16="http://schemas.microsoft.com/office/drawing/2014/main" val="2844735022"/>
+                    </a:ext>
+                  </a:extLst>
+                </a:gridCol>
+                <a:gridCol w="1227667">
+                  <a:extLst>
+                    <a:ext uri="{9D8B030D-6E8A-4147-A177-3AD203B41FA5}">
+                      <a16:colId xmlns:a16="http://schemas.microsoft.com/office/drawing/2014/main" val="1773775258"/>
+                    </a:ext>
+                  </a:extLst>
+                </a:gridCol>
+              </a:tblGrid>
+              <a:tr h="846667">
+                <a:tc>
+                  <a:txBody>
+                    <a:bodyPr/>
+                    <a:lstStyle/>
+                    <a:p>
+                      <a:r>
+                        <a:rPr lang="de-DE"/>
+                        <a:t>R1C1</a:t>
+                      </a:r>
+                    </a:p>
+                  </a:txBody>
+                  <a:tcPr/>
+                </a:tc>
+                <a:tc>
+                  <a:txBody>
+                    <a:bodyPr/>
+                    <a:lstStyle/>
+                    <a:p>
+                      <a:r>
+                        <a:rPr lang="de-DE"/>
+                        <a:t>R1C2</a:t>
+                      </a:r>
+                    </a:p>
+                  </a:txBody>
+                  <a:tcPr/>
+                </a:tc>
+                <a:tc>
+                  <a:txBody>
+                    <a:bodyPr/>
+                    <a:lstStyle/>
+                    <a:p>
+                      <a:r>
+                        <a:rPr lang="de-DE"/>
+                        <a:t>R1C3</a:t>
+                      </a:r>
+                    </a:p>
+                  </a:txBody>
+                  <a:tcPr/>
+                </a:tc>
+                <a:extLst>
+                  <a:ext uri="{0D108BD9-81ED-4DB2-BD59-A6C34878D82A}">
+                    <a16:rowId xmlns:a16="http://schemas.microsoft.com/office/drawing/2014/main" val="2039924307"/>
+                  </a:ext>
+                </a:extLst>
+              </a:tr>
+              <a:tr h="846667">
+                <a:tc>
+                  <a:txBody>
+                    <a:bodyPr/>
+                    <a:lstStyle/>
+                    <a:p>
+                      <a:r>
+                        <a:rPr lang="de-DE"/>
+                        <a:t>R2C1</a:t>
+                      </a:r>
+                    </a:p>
+                  </a:txBody>
+                  <a:tcPr/>
+                </a:tc>
+                <a:tc>
+                  <a:txBody>
+                    <a:bodyPr/>
+                    <a:lstStyle/>
+                    <a:p>
+                      <a:r>
+                        <a:rPr lang="de-DE"/>
+                        <a:t>R2C2</a:t>
+                      </a:r>
+                    </a:p>
+                  </a:txBody>
+                  <a:tcPr/>
+                </a:tc>
+                <a:tc>
+                  <a:txBody>
+                    <a:bodyPr/>
+                    <a:lstStyle/>
+                    <a:p>
+                      <a:r>
+                        <a:rPr lang="de-DE"/>
+                        <a:t>R2C3</a:t>
+                      </a:r>
+                    </a:p>
+                  </a:txBody>
+                  <a:tcPr/>
+                </a:tc>
+                <a:extLst>
+                  <a:ext uri="{0D108BD9-81ED-4DB2-BD59-A6C34878D82A}">
+                    <a16:rowId xmlns:a16="http://schemas.microsoft.com/office/drawing/2014/main" val="616729208"/>
+                  </a:ext>
+                </a:extLst>
+              </a:tr>
+              <a:tr h="846667">
+                <a:tc>
+                  <a:txBody>
+                    <a:bodyPr/>
+                    <a:lstStyle/>
+                    <a:p>
+                      <a:r>
+                        <a:rPr lang="de-DE"/>
+                        <a:t>R3C1</a:t>
+                      </a:r>
+                    </a:p>
+                  </a:txBody>
+                  <a:tcPr/>
+                </a:tc>
+                <a:tc>
+                  <a:txBody>
+                    <a:bodyPr/>
+                    <a:lstStyle/>
+                    <a:p>
+                      <a:r>
+                        <a:rPr lang="de-DE"/>
+                        <a:t>R3C2</a:t>
+                      </a:r>
+                    </a:p>
+                  </a:txBody>
+                  <a:tcPr/>
+                </a:tc>
+                <a:tc>
+                  <a:txBody>
+                    <a:bodyPr/>
+                    <a:lstStyle/>
+                    <a:p>
+                      <a:r>
+                        <a:rPr lang="de-DE"/>
+                        <a:t>R3C3</a:t>
+                      </a:r>
+                    </a:p>
+                  </a:txBody>
+                  <a:tcPr/>
+                </a:tc>
+                <a:extLst>
+                  <a:ext uri="{0D108BD9-81ED-4DB2-BD59-A6C34878D82A}">
+                    <a16:rowId xmlns:a16="http://schemas.microsoft.com/office/drawing/2014/main" val="2545987956"/>
+                  </a:ext>
+                </a:extLst>
+              </a:tr>
+            </a:tbl>
+          </a:graphicData>
+        </a:graphic>
+      </p:graphicFrame>
+      <p:graphicFrame>
+        <p:nvGraphicFramePr>
+          <p:cNvPr id="5" name="Tabelle 4">
+            <a:extLst>
+              <a:ext uri="{FF2B5EF4-FFF2-40B4-BE49-F238E27FC236}">
+                <a16:creationId xmlns:a16="http://schemas.microsoft.com/office/drawing/2014/main" id="{32866673-8BA7-EF82-F14B-F4CD689B615E}"/>
+              </a:ext>
+            </a:extLst>
+          </p:cNvPr>
+          <p:cNvGraphicFramePr>
+            <a:graphicFrameLocks noGrp="1"/>
+          </p:cNvGraphicFramePr>
+          <p:nvPr>
+            <p:extLst>
+              <p:ext uri="{D42A27DB-BD31-4B8C-83A1-F6EECF244321}">
+                <p14:modId xmlns:p14="http://schemas.microsoft.com/office/powerpoint/2010/main" val="3045191257"/>
+              </p:ext>
+            </p:extLst>
+          </p:nvPr>
+        </p:nvGraphicFramePr>
+        <p:xfrm>
+          <a:off x="381000" y="3683000"/>
+          <a:ext cx="3683000" cy="2540000"/>
+        </p:xfrm>
+        <a:graphic>
+          <a:graphicData uri="http://schemas.openxmlformats.org/drawingml/2006/table">
+            <a:tbl>
+              <a:tblPr firstRow="1" bandRow="1">
+                <a:tableStyleId>{775DCB02-9BB8-47FD-8907-85C794F793BA}</a:tableStyleId>
+              </a:tblPr>
+              <a:tblGrid>
+                <a:gridCol w="1227667">
+                  <a:extLst>
+                    <a:ext uri="{9D8B030D-6E8A-4147-A177-3AD203B41FA5}">
+                      <a16:colId xmlns:a16="http://schemas.microsoft.com/office/drawing/2014/main" val="3309100355"/>
+                    </a:ext>
+                  </a:extLst>
+                </a:gridCol>
+                <a:gridCol w="1227667">
+                  <a:extLst>
+                    <a:ext uri="{9D8B030D-6E8A-4147-A177-3AD203B41FA5}">
+                      <a16:colId xmlns:a16="http://schemas.microsoft.com/office/drawing/2014/main" val="3040499460"/>
+                    </a:ext>
+                  </a:extLst>
+                </a:gridCol>
+                <a:gridCol w="1227667">
+                  <a:extLst>
+                    <a:ext uri="{9D8B030D-6E8A-4147-A177-3AD203B41FA5}">
+                      <a16:colId xmlns:a16="http://schemas.microsoft.com/office/drawing/2014/main" val="3552182360"/>
+                    </a:ext>
+                  </a:extLst>
+                </a:gridCol>
+              </a:tblGrid>
+              <a:tr h="846667">
+                <a:tc>
+                  <a:txBody>
+                    <a:bodyPr/>
+                    <a:lstStyle/>
+                    <a:p>
+                      <a:r>
+                        <a:rPr lang="de-DE"/>
+                        <a:t>R1C1</a:t>
+                      </a:r>
+                    </a:p>
+                  </a:txBody>
+                  <a:tcPr/>
+                </a:tc>
+                <a:tc>
+                  <a:txBody>
+                    <a:bodyPr/>
+                    <a:lstStyle/>
+                    <a:p>
+                      <a:r>
+                        <a:rPr lang="de-DE"/>
+                        <a:t>R1C2</a:t>
+                      </a:r>
+                    </a:p>
+                  </a:txBody>
+                  <a:tcPr/>
+                </a:tc>
+                <a:tc>
+                  <a:txBody>
+                    <a:bodyPr/>
+                    <a:lstStyle/>
+                    <a:p>
+                      <a:r>
+                        <a:rPr lang="de-DE"/>
+                        <a:t>R1C3</a:t>
+                      </a:r>
+                    </a:p>
+                  </a:txBody>
+                  <a:tcPr/>
+                </a:tc>
+                <a:extLst>
+                  <a:ext uri="{0D108BD9-81ED-4DB2-BD59-A6C34878D82A}">
+                    <a16:rowId xmlns:a16="http://schemas.microsoft.com/office/drawing/2014/main" val="4246739601"/>
+                  </a:ext>
+                </a:extLst>
+              </a:tr>
+              <a:tr h="846667">
+                <a:tc>
+                  <a:txBody>
+                    <a:bodyPr/>
+                    <a:lstStyle/>
+                    <a:p>
+                      <a:r>
+                        <a:rPr lang="de-DE"/>
+                        <a:t>R2C1</a:t>
+                      </a:r>
+                    </a:p>
+                  </a:txBody>
+                  <a:tcPr/>
+                </a:tc>
+                <a:tc>
+                  <a:txBody>
+                    <a:bodyPr/>
+                    <a:lstStyle/>
+                    <a:p>
+                      <a:r>
+                        <a:rPr lang="de-DE"/>
+                        <a:t>R2C2</a:t>
+                      </a:r>
+                    </a:p>
+                  </a:txBody>
+                  <a:tcPr/>
+                </a:tc>
+                <a:tc>
+                  <a:txBody>
+                    <a:bodyPr/>
+                    <a:lstStyle/>
+                    <a:p>
+                      <a:r>
+                        <a:rPr lang="de-DE"/>
+                        <a:t>R2C3</a:t>
+                      </a:r>
+                    </a:p>
+                  </a:txBody>
+                  <a:tcPr/>
+                </a:tc>
+                <a:extLst>
+                  <a:ext uri="{0D108BD9-81ED-4DB2-BD59-A6C34878D82A}">
+                    <a16:rowId xmlns:a16="http://schemas.microsoft.com/office/drawing/2014/main" val="1778383731"/>
+                  </a:ext>
+                </a:extLst>
+              </a:tr>
+              <a:tr h="846667">
+                <a:tc>
+                  <a:txBody>
+                    <a:bodyPr/>
+                    <a:lstStyle/>
+                    <a:p>
+                      <a:r>
+                        <a:rPr lang="de-DE"/>
+                        <a:t>R3C1</a:t>
+                      </a:r>
+                    </a:p>
+                  </a:txBody>
+                  <a:tcPr/>
+                </a:tc>
+                <a:tc>
+                  <a:txBody>
+                    <a:bodyPr/>
+                    <a:lstStyle/>
+                    <a:p>
+                      <a:r>
+                        <a:rPr lang="de-DE"/>
+                        <a:t>R3C2</a:t>
+                      </a:r>
+                    </a:p>
+                  </a:txBody>
+                  <a:tcPr/>
+                </a:tc>
+                <a:tc>
+                  <a:txBody>
+                    <a:bodyPr/>
+                    <a:lstStyle/>
+                    <a:p>
+                      <a:r>
+                        <a:rPr lang="de-DE"/>
+                        <a:t>R3C3</a:t>
+                      </a:r>
+                    </a:p>
+                  </a:txBody>
+                  <a:tcPr/>
+                </a:tc>
+                <a:extLst>
+                  <a:ext uri="{0D108BD9-81ED-4DB2-BD59-A6C34878D82A}">
+                    <a16:rowId xmlns:a16="http://schemas.microsoft.com/office/drawing/2014/main" val="3811462499"/>
+                  </a:ext>
+                </a:extLst>
+              </a:tr>
+            </a:tbl>
+          </a:graphicData>
+        </a:graphic>
+      </p:graphicFrame>
+      <p:graphicFrame>
+        <p:nvGraphicFramePr>
+          <p:cNvPr id="6" name="Tabelle 5">
+            <a:extLst>
+              <a:ext uri="{FF2B5EF4-FFF2-40B4-BE49-F238E27FC236}">
+                <a16:creationId xmlns:a16="http://schemas.microsoft.com/office/drawing/2014/main" id="{0839780C-23C7-D0B9-C771-C3CDF5761F2E}"/>
+              </a:ext>
+            </a:extLst>
+          </p:cNvPr>
+          <p:cNvGraphicFramePr>
+            <a:graphicFrameLocks noGrp="1"/>
+          </p:cNvGraphicFramePr>
+          <p:nvPr>
+            <p:extLst>
+              <p:ext uri="{D42A27DB-BD31-4B8C-83A1-F6EECF244321}">
+                <p14:modId xmlns:p14="http://schemas.microsoft.com/office/powerpoint/2010/main" val="594387337"/>
+              </p:ext>
+            </p:extLst>
+          </p:nvPr>
+        </p:nvGraphicFramePr>
+        <p:xfrm>
+          <a:off x="4318000" y="3683000"/>
+          <a:ext cx="3683000" cy="2540000"/>
+        </p:xfrm>
+        <a:graphic>
+          <a:graphicData uri="http://schemas.openxmlformats.org/drawingml/2006/table">
+            <a:tbl>
+              <a:tblPr firstRow="1" bandRow="1">
+                <a:tableStyleId>{EB9631B5-78F2-41C9-869B-9F39066F8104}</a:tableStyleId>
+              </a:tblPr>
+              <a:tblGrid>
+                <a:gridCol w="1227667">
+                  <a:extLst>
+                    <a:ext uri="{9D8B030D-6E8A-4147-A177-3AD203B41FA5}">
+                      <a16:colId xmlns:a16="http://schemas.microsoft.com/office/drawing/2014/main" val="192694355"/>
+                    </a:ext>
+                  </a:extLst>
+                </a:gridCol>
+                <a:gridCol w="1227667">
+                  <a:extLst>
+                    <a:ext uri="{9D8B030D-6E8A-4147-A177-3AD203B41FA5}">
+                      <a16:colId xmlns:a16="http://schemas.microsoft.com/office/drawing/2014/main" val="675620702"/>
+                    </a:ext>
+                  </a:extLst>
+                </a:gridCol>
+                <a:gridCol w="1227667">
+                  <a:extLst>
+                    <a:ext uri="{9D8B030D-6E8A-4147-A177-3AD203B41FA5}">
+                      <a16:colId xmlns:a16="http://schemas.microsoft.com/office/drawing/2014/main" val="2789391815"/>
+                    </a:ext>
+                  </a:extLst>
+                </a:gridCol>
+              </a:tblGrid>
+              <a:tr h="846667">
+                <a:tc>
+                  <a:txBody>
+                    <a:bodyPr/>
+                    <a:lstStyle/>
+                    <a:p>
+                      <a:r>
+                        <a:rPr lang="de-DE"/>
+                        <a:t>R1C1</a:t>
+                      </a:r>
+                    </a:p>
+                  </a:txBody>
+                  <a:tcPr/>
+                </a:tc>
+                <a:tc>
+                  <a:txBody>
+                    <a:bodyPr/>
+                    <a:lstStyle/>
+                    <a:p>
+                      <a:r>
+                        <a:rPr lang="de-DE"/>
+                        <a:t>R1C2</a:t>
+                      </a:r>
+                    </a:p>
+                  </a:txBody>
+                  <a:tcPr/>
+                </a:tc>
+                <a:tc>
+                  <a:txBody>
+                    <a:bodyPr/>
+                    <a:lstStyle/>
+                    <a:p>
+                      <a:r>
+                        <a:rPr lang="de-DE"/>
+                        <a:t>R1C3</a:t>
+                      </a:r>
+                    </a:p>
+                  </a:txBody>
+                  <a:tcPr/>
+                </a:tc>
+                <a:extLst>
+                  <a:ext uri="{0D108BD9-81ED-4DB2-BD59-A6C34878D82A}">
+                    <a16:rowId xmlns:a16="http://schemas.microsoft.com/office/drawing/2014/main" val="3128336925"/>
+                  </a:ext>
+                </a:extLst>
+              </a:tr>
+              <a:tr h="846667">
+                <a:tc>
+                  <a:txBody>
+                    <a:bodyPr/>
+                    <a:lstStyle/>
+                    <a:p>
+                      <a:r>
+                        <a:rPr lang="de-DE"/>
+                        <a:t>R2C1</a:t>
+                      </a:r>
+                    </a:p>
+                  </a:txBody>
+                  <a:tcPr/>
+                </a:tc>
+                <a:tc>
+                  <a:txBody>
+                    <a:bodyPr/>
+                    <a:lstStyle/>
+                    <a:p>
+                      <a:r>
+                        <a:rPr lang="de-DE"/>
+                        <a:t>R2C2</a:t>
+                      </a:r>
+                    </a:p>
+                  </a:txBody>
+                  <a:tcPr/>
+                </a:tc>
+                <a:tc>
+                  <a:txBody>
+                    <a:bodyPr/>
+                    <a:lstStyle/>
+                    <a:p>
+                      <a:r>
+                        <a:rPr lang="de-DE"/>
+                        <a:t>R2C3</a:t>
+                      </a:r>
+                    </a:p>
+                  </a:txBody>
+                  <a:tcPr/>
+                </a:tc>
+                <a:extLst>
+                  <a:ext uri="{0D108BD9-81ED-4DB2-BD59-A6C34878D82A}">
+                    <a16:rowId xmlns:a16="http://schemas.microsoft.com/office/drawing/2014/main" val="161410010"/>
+                  </a:ext>
+                </a:extLst>
+              </a:tr>
+              <a:tr h="846667">
+                <a:tc>
+                  <a:txBody>
+                    <a:bodyPr/>
+                    <a:lstStyle/>
+                    <a:p>
+                      <a:r>
+                        <a:rPr lang="de-DE"/>
+                        <a:t>R3C1</a:t>
+                      </a:r>
+                    </a:p>
+                  </a:txBody>
+                  <a:tcPr/>
+                </a:tc>
+                <a:tc>
+                  <a:txBody>
+                    <a:bodyPr/>
+                    <a:lstStyle/>
+                    <a:p>
+                      <a:r>
+                        <a:rPr lang="de-DE"/>
+                        <a:t>R3C2</a:t>
+                      </a:r>
+                    </a:p>
+                  </a:txBody>
+                  <a:tcPr/>
+                </a:tc>
+                <a:tc>
+                  <a:txBody>
+                    <a:bodyPr/>
+                    <a:lstStyle/>
+                    <a:p>
+                      <a:r>
+                        <a:rPr lang="de-DE"/>
+                        <a:t>R3C3</a:t>
+                      </a:r>
+                    </a:p>
+                  </a:txBody>
+                  <a:tcPr/>
+                </a:tc>
+                <a:extLst>
+                  <a:ext uri="{0D108BD9-81ED-4DB2-BD59-A6C34878D82A}">
+                    <a16:rowId xmlns:a16="http://schemas.microsoft.com/office/drawing/2014/main" val="3411427212"/>
+                  </a:ext>
+                </a:extLst>
+              </a:tr>
+            </a:tbl>
+          </a:graphicData>
+        </a:graphic>
+      </p:graphicFrame>
+      <p:graphicFrame>
+        <p:nvGraphicFramePr>
+          <p:cNvPr id="7" name="Tabelle 6">
+            <a:extLst>
+              <a:ext uri="{FF2B5EF4-FFF2-40B4-BE49-F238E27FC236}">
+                <a16:creationId xmlns:a16="http://schemas.microsoft.com/office/drawing/2014/main" id="{13556D29-E17C-58E0-296C-C1A4961A3128}"/>
+              </a:ext>
+            </a:extLst>
+          </p:cNvPr>
+          <p:cNvGraphicFramePr>
+            <a:graphicFrameLocks noGrp="1"/>
+          </p:cNvGraphicFramePr>
+          <p:nvPr>
+            <p:extLst>
+              <p:ext uri="{D42A27DB-BD31-4B8C-83A1-F6EECF244321}">
+                <p14:modId xmlns:p14="http://schemas.microsoft.com/office/powerpoint/2010/main" val="2124402341"/>
+              </p:ext>
+            </p:extLst>
+          </p:nvPr>
+        </p:nvGraphicFramePr>
+        <p:xfrm>
+          <a:off x="8255000" y="3683000"/>
+          <a:ext cx="3683000" cy="2540000"/>
+        </p:xfrm>
+        <a:graphic>
+          <a:graphicData uri="http://schemas.openxmlformats.org/drawingml/2006/table">
+            <a:tbl>
+              <a:tblPr firstRow="1" bandRow="1">
+                <a:tableStyleId>{616DA210-FB5B-4158-B5E0-FEB733F419BA}</a:tableStyleId>
+              </a:tblPr>
+              <a:tblGrid>
+                <a:gridCol w="1227667">
+                  <a:extLst>
+                    <a:ext uri="{9D8B030D-6E8A-4147-A177-3AD203B41FA5}">
+                      <a16:colId xmlns:a16="http://schemas.microsoft.com/office/drawing/2014/main" val="2966043079"/>
+                    </a:ext>
+                  </a:extLst>
+                </a:gridCol>
+                <a:gridCol w="1227667">
+                  <a:extLst>
+                    <a:ext uri="{9D8B030D-6E8A-4147-A177-3AD203B41FA5}">
+                      <a16:colId xmlns:a16="http://schemas.microsoft.com/office/drawing/2014/main" val="1314929073"/>
+                    </a:ext>
+                  </a:extLst>
+                </a:gridCol>
+                <a:gridCol w="1227667">
+                  <a:extLst>
+                    <a:ext uri="{9D8B030D-6E8A-4147-A177-3AD203B41FA5}">
+                      <a16:colId xmlns:a16="http://schemas.microsoft.com/office/drawing/2014/main" val="592757786"/>
+                    </a:ext>
+                  </a:extLst>
+                </a:gridCol>
+              </a:tblGrid>
+              <a:tr h="846667">
+                <a:tc>
+                  <a:txBody>
+                    <a:bodyPr/>
+                    <a:lstStyle/>
+                    <a:p>
+                      <a:r>
+                        <a:rPr lang="de-DE"/>
+                        <a:t>R1C1</a:t>
+                      </a:r>
+                    </a:p>
+                  </a:txBody>
+                  <a:tcPr/>
+                </a:tc>
+                <a:tc>
+                  <a:txBody>
+                    <a:bodyPr/>
+                    <a:lstStyle/>
+                    <a:p>
+                      <a:r>
+                        <a:rPr lang="de-DE"/>
+                        <a:t>R1C2</a:t>
+                      </a:r>
+                    </a:p>
+                  </a:txBody>
+                  <a:tcPr/>
+                </a:tc>
+                <a:tc>
+                  <a:txBody>
+                    <a:bodyPr/>
+                    <a:lstStyle/>
+                    <a:p>
+                      <a:r>
+                        <a:rPr lang="de-DE"/>
+                        <a:t>R1C3</a:t>
+                      </a:r>
+                    </a:p>
+                  </a:txBody>
+                  <a:tcPr/>
+                </a:tc>
+                <a:extLst>
+                  <a:ext uri="{0D108BD9-81ED-4DB2-BD59-A6C34878D82A}">
+                    <a16:rowId xmlns:a16="http://schemas.microsoft.com/office/drawing/2014/main" val="3576190168"/>
+                  </a:ext>
+                </a:extLst>
+              </a:tr>
+              <a:tr h="846667">
+                <a:tc>
+                  <a:txBody>
+                    <a:bodyPr/>
+                    <a:lstStyle/>
+                    <a:p>
+                      <a:r>
+                        <a:rPr lang="de-DE"/>
+                        <a:t>R2C1</a:t>
+                      </a:r>
+                    </a:p>
+                  </a:txBody>
+                  <a:tcPr/>
+                </a:tc>
+                <a:tc>
+                  <a:txBody>
+                    <a:bodyPr/>
+                    <a:lstStyle/>
+                    <a:p>
+                      <a:r>
+                        <a:rPr lang="de-DE"/>
+                        <a:t>R2C2</a:t>
+                      </a:r>
+                    </a:p>
+                  </a:txBody>
+                  <a:tcPr/>
+                </a:tc>
+                <a:tc>
+                  <a:txBody>
+                    <a:bodyPr/>
+                    <a:lstStyle/>
+                    <a:p>
+                      <a:r>
+                        <a:rPr lang="de-DE"/>
+                        <a:t>R2C3</a:t>
+                      </a:r>
+                    </a:p>
+                  </a:txBody>
+                  <a:tcPr/>
+                </a:tc>
+                <a:extLst>
+                  <a:ext uri="{0D108BD9-81ED-4DB2-BD59-A6C34878D82A}">
+                    <a16:rowId xmlns:a16="http://schemas.microsoft.com/office/drawing/2014/main" val="369437670"/>
+                  </a:ext>
+                </a:extLst>
+              </a:tr>
+              <a:tr h="846667">
+                <a:tc>
+                  <a:txBody>
+                    <a:bodyPr/>
+                    <a:lstStyle/>
+                    <a:p>
+                      <a:r>
+                        <a:rPr lang="de-DE"/>
+                        <a:t>R3C1</a:t>
+                      </a:r>
+                    </a:p>
+                  </a:txBody>
+                  <a:tcPr/>
+                </a:tc>
+                <a:tc>
+                  <a:txBody>
+                    <a:bodyPr/>
+                    <a:lstStyle/>
+                    <a:p>
+                      <a:r>
+                        <a:rPr lang="de-DE"/>
+                        <a:t>R3C2</a:t>
+                      </a:r>
+                    </a:p>
+                  </a:txBody>
+                  <a:tcPr/>
+                </a:tc>
+                <a:tc>
+                  <a:txBody>
+                    <a:bodyPr/>
+                    <a:lstStyle/>
+                    <a:p>
+                      <a:r>
+                        <a:rPr lang="de-DE"/>
+                        <a:t>R3C3</a:t>
+                      </a:r>
+                    </a:p>
+                  </a:txBody>
+                  <a:tcPr/>
+                </a:tc>
+                <a:extLst>
+                  <a:ext uri="{0D108BD9-81ED-4DB2-BD59-A6C34878D82A}">
+                    <a16:rowId xmlns:a16="http://schemas.microsoft.com/office/drawing/2014/main" val="2865838750"/>
+                  </a:ext>
+                </a:extLst>
+              </a:tr>
+            </a:tbl>
+          </a:graphicData>
+        </a:graphic>
+      </p:graphicFrame>
+    </p:spTree>
+    <p:extLst>
+      <p:ext uri="{BB962C8B-B14F-4D97-AF65-F5344CB8AC3E}">
+        <p14:creationId xmlns:p14="http://schemas.microsoft.com/office/powerpoint/2010/main" val="1866552019"/>
       </p:ext>
     </p:extLst>
   </p:cSld>

</xml_diff>